<commit_message>
Regenerate: PDF-only case with hidden .pdf.md companions, task briefs in README, new overview deck, IMDA skill
- Spreadsheets and EVAL-02 ship as PDF plus hidden X.pdf.md; XLSX/CSV dropped
- Drop CLAR-01; move EMAIL-01 to 01-project-and-grant
- Fold Task 1-3 materials into README; remove 06-task-materials
- Fold INITIAL-02 dashboard into the INITIAL-01 memo PDF; drop its DOCX
- INITIAL-03 deck: overview slide, PASS/FAIL colours, explicit recommendation, design-faithful PDF and sidecar
- Add .vscode.student, CLAUDE.md.student, attribution.schema.json
- Bundle deck template in pptx-generator; add imda-ai-governance skill

Co-Authored-By: Claude Opus 5.5 <noreply@anthropic.com>
Claude-Session: https://claude.ai/code/session_0114iFt1PAdDoDHFkZMRKzse
</commit_message>
<xml_diff>
--- a/case/05-initial-output/INITIAL-03-initial-leadership-selection-deck.pptx
+++ b/case/05-initial-output/INITIAL-03-initial-leadership-selection-deck.pptx
@@ -5,9 +5,9 @@
     <p:sldMasterId id="2147483660" r:id="rId1"/>
   </p:sldMasterIdLst>
   <p:sldIdLst>
-    <p:sldId r:id="rId9-created" id="256"/>
-    <p:sldId r:id="rId10-created" id="257"/>
-    <p:sldId r:id="rId11-created" id="258"/>
+    <p:sldId r:id="rId10-created" id="256"/>
+    <p:sldId r:id="rId11-created" id="257"/>
+    <p:sldId r:id="rId12-created" id="258"/>
   </p:sldIdLst>
   <p:sldSz cx="12192000" cy="6858000"/>
   <p:notesSz cx="6858000" cy="9144000"/>
@@ -1852,7 +1852,7 @@
           <a:p>
             <a:pPr algn="l"/>
             <a:r>
-              <a:rPr lang="en-US" sz="1000" b="1" i="0" dirty="0">
+              <a:rPr lang="en-US" sz="1300" b="1" i="0" dirty="0">
                 <a:solidFill>
                   <a:srgbClr val="44546A"/>
                 </a:solidFill>
@@ -1982,7 +1982,7 @@
           <a:p>
             <a:pPr algn="l"/>
             <a:r>
-              <a:rPr lang="en-US" sz="1250" b="1" i="0" dirty="0">
+              <a:rPr lang="en-US" sz="1300" b="1" i="0" dirty="0">
                 <a:solidFill>
                   <a:srgbClr val="003087"/>
                 </a:solidFill>
@@ -2017,7 +2017,7 @@
           <a:p>
             <a:pPr algn="l"/>
             <a:r>
-              <a:rPr lang="en-US" sz="1250" b="1" i="0" dirty="0">
+              <a:rPr lang="en-US" sz="1300" b="1" i="0" dirty="0">
                 <a:solidFill>
                   <a:srgbClr val="003087"/>
                 </a:solidFill>
@@ -2081,7 +2081,7 @@
           <a:p>
             <a:pPr algn="l"/>
             <a:r>
-              <a:rPr lang="en-US" sz="850" b="1" i="0" dirty="0">
+              <a:rPr lang="en-US" sz="1300" b="1" i="0" dirty="0">
                 <a:solidFill>
                   <a:srgbClr val="44546A"/>
                 </a:solidFill>
@@ -2116,7 +2116,7 @@
           <a:p>
             <a:pPr algn="l"/>
             <a:r>
-              <a:rPr lang="en-US" sz="850" b="1" i="0" dirty="0">
+              <a:rPr lang="en-US" sz="1300" b="1" i="0" dirty="0">
                 <a:solidFill>
                   <a:srgbClr val="44546A"/>
                 </a:solidFill>
@@ -2151,7 +2151,7 @@
           <a:p>
             <a:pPr algn="l"/>
             <a:r>
-              <a:rPr lang="en-US" sz="850" b="1" i="0" dirty="0">
+              <a:rPr lang="en-US" sz="1300" b="1" i="0" dirty="0">
                 <a:solidFill>
                   <a:srgbClr val="44546A"/>
                 </a:solidFill>
@@ -2215,7 +2215,7 @@
           <a:p>
             <a:pPr algn="l"/>
             <a:r>
-              <a:rPr lang="en-US" sz="1050" b="1" i="0" dirty="0">
+              <a:rPr lang="en-US" sz="1300" b="1" i="0" dirty="0">
                 <a:solidFill>
                   <a:srgbClr val="1A1A2E"/>
                 </a:solidFill>
@@ -2250,7 +2250,7 @@
           <a:p>
             <a:pPr algn="l"/>
             <a:r>
-              <a:rPr lang="en-US" sz="850" b="1" i="0" dirty="0">
+              <a:rPr lang="en-US" sz="1300" b="1" i="0" dirty="0">
                 <a:solidFill>
                   <a:srgbClr val="44546A"/>
                 </a:solidFill>
@@ -2285,7 +2285,7 @@
           <a:p>
             <a:pPr algn="l"/>
             <a:r>
-              <a:rPr lang="en-US" sz="900" b="0" i="0" dirty="0">
+              <a:rPr lang="en-US" sz="1300" b="0" i="0" dirty="0">
                 <a:solidFill>
                   <a:srgbClr val="44546A"/>
                 </a:solidFill>
@@ -2349,7 +2349,7 @@
           <a:p>
             <a:pPr algn="l"/>
             <a:r>
-              <a:rPr lang="en-US" sz="1050" b="1" i="0" dirty="0">
+              <a:rPr lang="en-US" sz="1300" b="1" i="0" dirty="0">
                 <a:solidFill>
                   <a:srgbClr val="1A1A2E"/>
                 </a:solidFill>
@@ -2384,7 +2384,7 @@
           <a:p>
             <a:pPr algn="l"/>
             <a:r>
-              <a:rPr lang="en-US" sz="850" b="1" i="0" dirty="0">
+              <a:rPr lang="en-US" sz="1300" b="1" i="0" dirty="0">
                 <a:solidFill>
                   <a:srgbClr val="44546A"/>
                 </a:solidFill>
@@ -2419,7 +2419,7 @@
           <a:p>
             <a:pPr algn="l"/>
             <a:r>
-              <a:rPr lang="en-US" sz="900" b="0" i="0" dirty="0">
+              <a:rPr lang="en-US" sz="1300" b="0" i="0" dirty="0">
                 <a:solidFill>
                   <a:srgbClr val="44546A"/>
                 </a:solidFill>
@@ -2483,7 +2483,7 @@
           <a:p>
             <a:pPr algn="l"/>
             <a:r>
-              <a:rPr lang="en-US" sz="1050" b="1" i="0" dirty="0">
+              <a:rPr lang="en-US" sz="1300" b="1" i="0" dirty="0">
                 <a:solidFill>
                   <a:srgbClr val="1A1A2E"/>
                 </a:solidFill>
@@ -2518,7 +2518,7 @@
           <a:p>
             <a:pPr algn="l"/>
             <a:r>
-              <a:rPr lang="en-US" sz="850" b="1" i="0" dirty="0">
+              <a:rPr lang="en-US" sz="1300" b="1" i="0" dirty="0">
                 <a:solidFill>
                   <a:srgbClr val="44546A"/>
                 </a:solidFill>
@@ -2553,7 +2553,7 @@
           <a:p>
             <a:pPr algn="l"/>
             <a:r>
-              <a:rPr lang="en-US" sz="900" b="0" i="0" dirty="0">
+              <a:rPr lang="en-US" sz="1300" b="0" i="0" dirty="0">
                 <a:solidFill>
                   <a:srgbClr val="44546A"/>
                 </a:solidFill>
@@ -2617,7 +2617,7 @@
           <a:p>
             <a:pPr algn="l"/>
             <a:r>
-              <a:rPr lang="en-US" sz="1050" b="1" i="0" dirty="0">
+              <a:rPr lang="en-US" sz="1300" b="1" i="0" dirty="0">
                 <a:solidFill>
                   <a:srgbClr val="1A1A2E"/>
                 </a:solidFill>
@@ -2652,7 +2652,7 @@
           <a:p>
             <a:pPr algn="l"/>
             <a:r>
-              <a:rPr lang="en-US" sz="850" b="1" i="0" dirty="0">
+              <a:rPr lang="en-US" sz="1300" b="1" i="0" dirty="0">
                 <a:solidFill>
                   <a:srgbClr val="44546A"/>
                 </a:solidFill>
@@ -2687,7 +2687,7 @@
           <a:p>
             <a:pPr algn="l"/>
             <a:r>
-              <a:rPr lang="en-US" sz="900" b="0" i="0" dirty="0">
+              <a:rPr lang="en-US" sz="1300" b="0" i="0" dirty="0">
                 <a:solidFill>
                   <a:srgbClr val="44546A"/>
                 </a:solidFill>
@@ -2751,7 +2751,7 @@
           <a:p>
             <a:pPr algn="l"/>
             <a:r>
-              <a:rPr lang="en-US" sz="1050" b="1" i="0" dirty="0">
+              <a:rPr lang="en-US" sz="1300" b="1" i="0" dirty="0">
                 <a:solidFill>
                   <a:srgbClr val="1A1A2E"/>
                 </a:solidFill>
@@ -2786,7 +2786,7 @@
           <a:p>
             <a:pPr algn="l"/>
             <a:r>
-              <a:rPr lang="en-US" sz="850" b="1" i="0" dirty="0">
+              <a:rPr lang="en-US" sz="1300" b="1" i="0" dirty="0">
                 <a:solidFill>
                   <a:srgbClr val="44546A"/>
                 </a:solidFill>
@@ -2821,7 +2821,7 @@
           <a:p>
             <a:pPr algn="l"/>
             <a:r>
-              <a:rPr lang="en-US" sz="900" b="0" i="0" dirty="0">
+              <a:rPr lang="en-US" sz="1300" b="0" i="0" dirty="0">
                 <a:solidFill>
                   <a:srgbClr val="44546A"/>
                 </a:solidFill>
@@ -2887,7 +2887,7 @@
           <a:p>
             <a:pPr algn="l"/>
             <a:r>
-              <a:rPr lang="en-US" sz="1050" b="1" i="0" dirty="0">
+              <a:rPr lang="en-US" sz="1300" b="1" i="0" dirty="0">
                 <a:solidFill>
                   <a:srgbClr val="1A1A2E"/>
                 </a:solidFill>
@@ -2984,7 +2984,7 @@
           <a:p>
             <a:pPr algn="r"/>
             <a:r>
-              <a:rPr lang="en-US" sz="1050" b="1" i="0" dirty="0">
+              <a:rPr lang="en-US" sz="1300" b="1" i="0" dirty="0">
                 <a:solidFill>
                   <a:srgbClr val="1A1A2E"/>
                 </a:solidFill>
@@ -3019,7 +3019,7 @@
           <a:p>
             <a:pPr algn="l"/>
             <a:r>
-              <a:rPr lang="en-US" sz="850" b="0" i="0" dirty="0">
+              <a:rPr lang="en-US" sz="1300" b="0" i="0" dirty="0">
                 <a:solidFill>
                   <a:srgbClr val="44546A"/>
                 </a:solidFill>
@@ -3054,7 +3054,7 @@
           <a:p>
             <a:pPr algn="l"/>
             <a:r>
-              <a:rPr lang="en-US" sz="1050" b="1" i="0" dirty="0">
+              <a:rPr lang="en-US" sz="1300" b="1" i="0" dirty="0">
                 <a:solidFill>
                   <a:srgbClr val="1A1A2E"/>
                 </a:solidFill>
@@ -3151,7 +3151,7 @@
           <a:p>
             <a:pPr algn="r"/>
             <a:r>
-              <a:rPr lang="en-US" sz="1050" b="1" i="0" dirty="0">
+              <a:rPr lang="en-US" sz="1300" b="1" i="0" dirty="0">
                 <a:solidFill>
                   <a:srgbClr val="1A1A2E"/>
                 </a:solidFill>
@@ -3186,7 +3186,7 @@
           <a:p>
             <a:pPr algn="l"/>
             <a:r>
-              <a:rPr lang="en-US" sz="850" b="0" i="0" dirty="0">
+              <a:rPr lang="en-US" sz="1300" b="0" i="0" dirty="0">
                 <a:solidFill>
                   <a:srgbClr val="44546A"/>
                 </a:solidFill>
@@ -3221,7 +3221,7 @@
           <a:p>
             <a:pPr algn="l"/>
             <a:r>
-              <a:rPr lang="en-US" sz="1050" b="1" i="0" dirty="0">
+              <a:rPr lang="en-US" sz="1300" b="1" i="0" dirty="0">
                 <a:solidFill>
                   <a:srgbClr val="1A1A2E"/>
                 </a:solidFill>
@@ -3318,7 +3318,7 @@
           <a:p>
             <a:pPr algn="r"/>
             <a:r>
-              <a:rPr lang="en-US" sz="1050" b="1" i="0" dirty="0">
+              <a:rPr lang="en-US" sz="1300" b="1" i="0" dirty="0">
                 <a:solidFill>
                   <a:srgbClr val="1A1A2E"/>
                 </a:solidFill>
@@ -3353,7 +3353,7 @@
           <a:p>
             <a:pPr algn="l"/>
             <a:r>
-              <a:rPr lang="en-US" sz="850" b="0" i="0" dirty="0">
+              <a:rPr lang="en-US" sz="1300" b="0" i="0" dirty="0">
                 <a:solidFill>
                   <a:srgbClr val="44546A"/>
                 </a:solidFill>
@@ -3454,13 +3454,13 @@
           <a:p>
             <a:pPr algn="l"/>
             <a:r>
-              <a:rPr lang="en-US" sz="850" b="0" i="0" dirty="0">
+              <a:rPr lang="en-US" sz="1300" b="0" i="0" dirty="0">
                 <a:solidFill>
                   <a:srgbClr val="44546A"/>
                 </a:solidFill>
                 <a:latin typeface="Open Sans" panose="020B0606030504020204" pitchFamily="34" charset="0"/>
               </a:rPr>
-              <a:t>Sources: document ID and exact locator. Fictional training case; not organisational policy or Singapore procurement law.</a:t>
+              <a:t>Sources: document ID and exact locator. Fictional training case.</a:t>
             </a:r>
           </a:p>
         </p:txBody>
@@ -3549,7 +3549,7 @@
           <a:p>
             <a:pPr algn="l"/>
             <a:r>
-              <a:rPr lang="en-US" sz="1000" b="1" i="0" dirty="0">
+              <a:rPr lang="en-US" sz="1300" b="1" i="0" dirty="0">
                 <a:solidFill>
                   <a:srgbClr val="44546A"/>
                 </a:solidFill>
@@ -3679,7 +3679,7 @@
           <a:p>
             <a:pPr algn="l"/>
             <a:r>
-              <a:rPr lang="en-US" sz="1250" b="1" i="0" dirty="0">
+              <a:rPr lang="en-US" sz="1300" b="1" i="0" dirty="0">
                 <a:solidFill>
                   <a:srgbClr val="003087"/>
                 </a:solidFill>
@@ -3714,7 +3714,7 @@
           <a:p>
             <a:pPr algn="l"/>
             <a:r>
-              <a:rPr lang="en-US" sz="1250" b="1" i="0" dirty="0">
+              <a:rPr lang="en-US" sz="1300" b="1" i="0" dirty="0">
                 <a:solidFill>
                   <a:srgbClr val="003087"/>
                 </a:solidFill>
@@ -3778,7 +3778,7 @@
           <a:p>
             <a:pPr algn="l"/>
             <a:r>
-              <a:rPr lang="en-US" sz="850" b="1" i="0" dirty="0">
+              <a:rPr lang="en-US" sz="1300" b="1" i="0" dirty="0">
                 <a:solidFill>
                   <a:srgbClr val="44546A"/>
                 </a:solidFill>
@@ -3813,7 +3813,7 @@
           <a:p>
             <a:pPr algn="l"/>
             <a:r>
-              <a:rPr lang="en-US" sz="850" b="1" i="0" dirty="0">
+              <a:rPr lang="en-US" sz="1300" b="1" i="0" dirty="0">
                 <a:solidFill>
                   <a:srgbClr val="44546A"/>
                 </a:solidFill>
@@ -3848,7 +3848,7 @@
           <a:p>
             <a:pPr algn="l"/>
             <a:r>
-              <a:rPr lang="en-US" sz="850" b="1" i="0" dirty="0">
+              <a:rPr lang="en-US" sz="1300" b="1" i="0" dirty="0">
                 <a:solidFill>
                   <a:srgbClr val="44546A"/>
                 </a:solidFill>
@@ -3912,7 +3912,7 @@
           <a:p>
             <a:pPr algn="l"/>
             <a:r>
-              <a:rPr lang="en-US" sz="1050" b="1" i="0" dirty="0">
+              <a:rPr lang="en-US" sz="1300" b="1" i="0" dirty="0">
                 <a:solidFill>
                   <a:srgbClr val="1A1A2E"/>
                 </a:solidFill>
@@ -3947,7 +3947,7 @@
           <a:p>
             <a:pPr algn="l"/>
             <a:r>
-              <a:rPr lang="en-US" sz="850" b="1" i="0" dirty="0">
+              <a:rPr lang="en-US" sz="1300" b="1" i="0" dirty="0">
                 <a:solidFill>
                   <a:srgbClr val="44546A"/>
                 </a:solidFill>
@@ -3982,7 +3982,7 @@
           <a:p>
             <a:pPr algn="l"/>
             <a:r>
-              <a:rPr lang="en-US" sz="900" b="0" i="0" dirty="0">
+              <a:rPr lang="en-US" sz="1300" b="0" i="0" dirty="0">
                 <a:solidFill>
                   <a:srgbClr val="44546A"/>
                 </a:solidFill>
@@ -4046,7 +4046,7 @@
           <a:p>
             <a:pPr algn="l"/>
             <a:r>
-              <a:rPr lang="en-US" sz="1050" b="1" i="0" dirty="0">
+              <a:rPr lang="en-US" sz="1300" b="1" i="0" dirty="0">
                 <a:solidFill>
                   <a:srgbClr val="1A1A2E"/>
                 </a:solidFill>
@@ -4081,7 +4081,7 @@
           <a:p>
             <a:pPr algn="l"/>
             <a:r>
-              <a:rPr lang="en-US" sz="850" b="1" i="0" dirty="0">
+              <a:rPr lang="en-US" sz="1300" b="1" i="0" dirty="0">
                 <a:solidFill>
                   <a:srgbClr val="44546A"/>
                 </a:solidFill>
@@ -4116,7 +4116,7 @@
           <a:p>
             <a:pPr algn="l"/>
             <a:r>
-              <a:rPr lang="en-US" sz="900" b="0" i="0" dirty="0">
+              <a:rPr lang="en-US" sz="1300" b="0" i="0" dirty="0">
                 <a:solidFill>
                   <a:srgbClr val="44546A"/>
                 </a:solidFill>
@@ -4180,7 +4180,7 @@
           <a:p>
             <a:pPr algn="l"/>
             <a:r>
-              <a:rPr lang="en-US" sz="1050" b="1" i="0" dirty="0">
+              <a:rPr lang="en-US" sz="1300" b="1" i="0" dirty="0">
                 <a:solidFill>
                   <a:srgbClr val="1A1A2E"/>
                 </a:solidFill>
@@ -4215,7 +4215,7 @@
           <a:p>
             <a:pPr algn="l"/>
             <a:r>
-              <a:rPr lang="en-US" sz="850" b="1" i="0" dirty="0">
+              <a:rPr lang="en-US" sz="1300" b="1" i="0" dirty="0">
                 <a:solidFill>
                   <a:srgbClr val="44546A"/>
                 </a:solidFill>
@@ -4250,7 +4250,7 @@
           <a:p>
             <a:pPr algn="l"/>
             <a:r>
-              <a:rPr lang="en-US" sz="900" b="0" i="0" dirty="0">
+              <a:rPr lang="en-US" sz="1300" b="0" i="0" dirty="0">
                 <a:solidFill>
                   <a:srgbClr val="44546A"/>
                 </a:solidFill>
@@ -4314,7 +4314,7 @@
           <a:p>
             <a:pPr algn="l"/>
             <a:r>
-              <a:rPr lang="en-US" sz="1050" b="1" i="0" dirty="0">
+              <a:rPr lang="en-US" sz="1300" b="1" i="0" dirty="0">
                 <a:solidFill>
                   <a:srgbClr val="1A1A2E"/>
                 </a:solidFill>
@@ -4349,7 +4349,7 @@
           <a:p>
             <a:pPr algn="l"/>
             <a:r>
-              <a:rPr lang="en-US" sz="850" b="1" i="0" dirty="0">
+              <a:rPr lang="en-US" sz="1300" b="1" i="0" dirty="0">
                 <a:solidFill>
                   <a:srgbClr val="44546A"/>
                 </a:solidFill>
@@ -4384,7 +4384,7 @@
           <a:p>
             <a:pPr algn="l"/>
             <a:r>
-              <a:rPr lang="en-US" sz="900" b="0" i="0" dirty="0">
+              <a:rPr lang="en-US" sz="1300" b="0" i="0" dirty="0">
                 <a:solidFill>
                   <a:srgbClr val="44546A"/>
                 </a:solidFill>
@@ -4448,7 +4448,7 @@
           <a:p>
             <a:pPr algn="l"/>
             <a:r>
-              <a:rPr lang="en-US" sz="1050" b="1" i="0" dirty="0">
+              <a:rPr lang="en-US" sz="1300" b="1" i="0" dirty="0">
                 <a:solidFill>
                   <a:srgbClr val="1A1A2E"/>
                 </a:solidFill>
@@ -4483,7 +4483,7 @@
           <a:p>
             <a:pPr algn="l"/>
             <a:r>
-              <a:rPr lang="en-US" sz="850" b="1" i="0" dirty="0">
+              <a:rPr lang="en-US" sz="1300" b="1" i="0" dirty="0">
                 <a:solidFill>
                   <a:srgbClr val="44546A"/>
                 </a:solidFill>
@@ -4518,7 +4518,7 @@
           <a:p>
             <a:pPr algn="l"/>
             <a:r>
-              <a:rPr lang="en-US" sz="900" b="0" i="0" dirty="0">
+              <a:rPr lang="en-US" sz="1300" b="0" i="0" dirty="0">
                 <a:solidFill>
                   <a:srgbClr val="44546A"/>
                 </a:solidFill>
@@ -4584,7 +4584,7 @@
           <a:p>
             <a:pPr algn="l"/>
             <a:r>
-              <a:rPr lang="en-US" sz="1050" b="1" i="0" dirty="0">
+              <a:rPr lang="en-US" sz="1300" b="1" i="0" dirty="0">
                 <a:solidFill>
                   <a:srgbClr val="1A1A2E"/>
                 </a:solidFill>
@@ -4681,7 +4681,7 @@
           <a:p>
             <a:pPr algn="r"/>
             <a:r>
-              <a:rPr lang="en-US" sz="1050" b="1" i="0" dirty="0">
+              <a:rPr lang="en-US" sz="1300" b="1" i="0" dirty="0">
                 <a:solidFill>
                   <a:srgbClr val="1A1A2E"/>
                 </a:solidFill>
@@ -4716,7 +4716,7 @@
           <a:p>
             <a:pPr algn="l"/>
             <a:r>
-              <a:rPr lang="en-US" sz="850" b="0" i="0" dirty="0">
+              <a:rPr lang="en-US" sz="1300" b="0" i="0" dirty="0">
                 <a:solidFill>
                   <a:srgbClr val="44546A"/>
                 </a:solidFill>
@@ -4751,7 +4751,7 @@
           <a:p>
             <a:pPr algn="l"/>
             <a:r>
-              <a:rPr lang="en-US" sz="1050" b="1" i="0" dirty="0">
+              <a:rPr lang="en-US" sz="1300" b="1" i="0" dirty="0">
                 <a:solidFill>
                   <a:srgbClr val="1A1A2E"/>
                 </a:solidFill>
@@ -4848,7 +4848,7 @@
           <a:p>
             <a:pPr algn="r"/>
             <a:r>
-              <a:rPr lang="en-US" sz="1050" b="1" i="0" dirty="0">
+              <a:rPr lang="en-US" sz="1300" b="1" i="0" dirty="0">
                 <a:solidFill>
                   <a:srgbClr val="1A1A2E"/>
                 </a:solidFill>
@@ -4883,7 +4883,7 @@
           <a:p>
             <a:pPr algn="l"/>
             <a:r>
-              <a:rPr lang="en-US" sz="850" b="0" i="0" dirty="0">
+              <a:rPr lang="en-US" sz="1300" b="0" i="0" dirty="0">
                 <a:solidFill>
                   <a:srgbClr val="44546A"/>
                 </a:solidFill>
@@ -4918,7 +4918,7 @@
           <a:p>
             <a:pPr algn="l"/>
             <a:r>
-              <a:rPr lang="en-US" sz="1050" b="1" i="0" dirty="0">
+              <a:rPr lang="en-US" sz="1300" b="1" i="0" dirty="0">
                 <a:solidFill>
                   <a:srgbClr val="1A1A2E"/>
                 </a:solidFill>
@@ -5015,7 +5015,7 @@
           <a:p>
             <a:pPr algn="r"/>
             <a:r>
-              <a:rPr lang="en-US" sz="1050" b="1" i="0" dirty="0">
+              <a:rPr lang="en-US" sz="1300" b="1" i="0" dirty="0">
                 <a:solidFill>
                   <a:srgbClr val="1A1A2E"/>
                 </a:solidFill>
@@ -5050,7 +5050,7 @@
           <a:p>
             <a:pPr algn="l"/>
             <a:r>
-              <a:rPr lang="en-US" sz="850" b="0" i="0" dirty="0">
+              <a:rPr lang="en-US" sz="1300" b="0" i="0" dirty="0">
                 <a:solidFill>
                   <a:srgbClr val="44546A"/>
                 </a:solidFill>
@@ -5151,13 +5151,13 @@
           <a:p>
             <a:pPr algn="l"/>
             <a:r>
-              <a:rPr lang="en-US" sz="850" b="0" i="0" dirty="0">
+              <a:rPr lang="en-US" sz="1300" b="0" i="0" dirty="0">
                 <a:solidFill>
                   <a:srgbClr val="44546A"/>
                 </a:solidFill>
                 <a:latin typeface="Open Sans" panose="020B0606030504020204" pitchFamily="34" charset="0"/>
               </a:rPr>
-              <a:t>Sources: document ID and exact locator. Fictional training case; not organisational policy or Singapore procurement law.</a:t>
+              <a:t>Sources: document ID and exact locator. Fictional training case.</a:t>
             </a:r>
           </a:p>
         </p:txBody>
@@ -5246,7 +5246,7 @@
           <a:p>
             <a:pPr algn="l"/>
             <a:r>
-              <a:rPr lang="en-US" sz="1000" b="1" i="0" dirty="0">
+              <a:rPr lang="en-US" sz="1300" b="1" i="0" dirty="0">
                 <a:solidFill>
                   <a:srgbClr val="44546A"/>
                 </a:solidFill>
@@ -5316,7 +5316,7 @@
           <a:p>
             <a:pPr algn="l"/>
             <a:r>
-              <a:rPr lang="en-US" sz="1150" b="1" i="0" dirty="0">
+              <a:rPr lang="en-US" sz="1300" b="1" i="0" dirty="0">
                 <a:solidFill>
                   <a:srgbClr val="003087"/>
                 </a:solidFill>
@@ -5351,7 +5351,7 @@
           <a:p>
             <a:pPr algn="l"/>
             <a:r>
-              <a:rPr lang="en-US" sz="1150" b="1" i="0" dirty="0">
+              <a:rPr lang="en-US" sz="1300" b="1" i="0" dirty="0">
                 <a:solidFill>
                   <a:srgbClr val="003087"/>
                 </a:solidFill>
@@ -5386,7 +5386,7 @@
           <a:p>
             <a:pPr algn="l"/>
             <a:r>
-              <a:rPr lang="en-US" sz="950" b="0" i="0" dirty="0">
+              <a:rPr lang="en-US" sz="1300" b="0" i="0" dirty="0">
                 <a:solidFill>
                   <a:srgbClr val="1A1A2E"/>
                 </a:solidFill>
@@ -5421,7 +5421,7 @@
           <a:p>
             <a:pPr algn="l"/>
             <a:r>
-              <a:rPr lang="en-US" sz="950" b="0" i="0" dirty="0">
+              <a:rPr lang="en-US" sz="1300" b="0" i="0" dirty="0">
                 <a:solidFill>
                   <a:srgbClr val="1A1A2E"/>
                 </a:solidFill>
@@ -5456,7 +5456,7 @@
           <a:p>
             <a:pPr algn="l"/>
             <a:r>
-              <a:rPr lang="en-US" sz="950" b="0" i="0" dirty="0">
+              <a:rPr lang="en-US" sz="1300" b="0" i="0" dirty="0">
                 <a:solidFill>
                   <a:srgbClr val="1A1A2E"/>
                 </a:solidFill>
@@ -5491,7 +5491,7 @@
           <a:p>
             <a:pPr algn="l"/>
             <a:r>
-              <a:rPr lang="en-US" sz="950" b="0" i="0" dirty="0">
+              <a:rPr lang="en-US" sz="1300" b="0" i="0" dirty="0">
                 <a:solidFill>
                   <a:srgbClr val="1A1A2E"/>
                 </a:solidFill>
@@ -5526,7 +5526,7 @@
           <a:p>
             <a:pPr algn="l"/>
             <a:r>
-              <a:rPr lang="en-US" sz="950" b="0" i="0" dirty="0">
+              <a:rPr lang="en-US" sz="1300" b="0" i="0" dirty="0">
                 <a:solidFill>
                   <a:srgbClr val="1A1A2E"/>
                 </a:solidFill>
@@ -5561,7 +5561,7 @@
           <a:p>
             <a:pPr algn="l"/>
             <a:r>
-              <a:rPr lang="en-US" sz="950" b="0" i="0" dirty="0">
+              <a:rPr lang="en-US" sz="1300" b="0" i="0" dirty="0">
                 <a:solidFill>
                   <a:srgbClr val="1A1A2E"/>
                 </a:solidFill>
@@ -5596,7 +5596,7 @@
           <a:p>
             <a:pPr algn="l"/>
             <a:r>
-              <a:rPr lang="en-US" sz="950" b="0" i="0" dirty="0">
+              <a:rPr lang="en-US" sz="1300" b="0" i="0" dirty="0">
                 <a:solidFill>
                   <a:srgbClr val="1A1A2E"/>
                 </a:solidFill>
@@ -5660,7 +5660,7 @@
           <a:p>
             <a:pPr algn="l"/>
             <a:r>
-              <a:rPr lang="en-US" sz="1050" b="1" i="0" dirty="0">
+              <a:rPr lang="en-US" sz="1300" b="1" i="0" dirty="0">
                 <a:solidFill>
                   <a:srgbClr val="1A1A2E"/>
                 </a:solidFill>
@@ -5695,7 +5695,7 @@
           <a:p>
             <a:pPr algn="r"/>
             <a:r>
-              <a:rPr lang="en-US" sz="1050" b="1" i="0" dirty="0">
+              <a:rPr lang="en-US" sz="1300" b="1" i="0" dirty="0">
                 <a:solidFill>
                   <a:srgbClr val="5C068C"/>
                 </a:solidFill>
@@ -5759,7 +5759,7 @@
           <a:p>
             <a:pPr algn="l"/>
             <a:r>
-              <a:rPr lang="en-US" sz="1050" b="1" i="0" dirty="0">
+              <a:rPr lang="en-US" sz="1300" b="1" i="0" dirty="0">
                 <a:solidFill>
                   <a:srgbClr val="1A1A2E"/>
                 </a:solidFill>
@@ -5794,7 +5794,7 @@
           <a:p>
             <a:pPr algn="r"/>
             <a:r>
-              <a:rPr lang="en-US" sz="1050" b="1" i="0" dirty="0">
+              <a:rPr lang="en-US" sz="1300" b="1" i="0" dirty="0">
                 <a:solidFill>
                   <a:srgbClr val="5C068C"/>
                 </a:solidFill>
@@ -5858,7 +5858,7 @@
           <a:p>
             <a:pPr algn="l"/>
             <a:r>
-              <a:rPr lang="en-US" sz="1050" b="1" i="0" dirty="0">
+              <a:rPr lang="en-US" sz="1300" b="1" i="0" dirty="0">
                 <a:solidFill>
                   <a:srgbClr val="1A1A2E"/>
                 </a:solidFill>
@@ -5893,7 +5893,7 @@
           <a:p>
             <a:pPr algn="r"/>
             <a:r>
-              <a:rPr lang="en-US" sz="1050" b="1" i="0" dirty="0">
+              <a:rPr lang="en-US" sz="1300" b="1" i="0" dirty="0">
                 <a:solidFill>
                   <a:srgbClr val="5C068C"/>
                 </a:solidFill>
@@ -5957,7 +5957,7 @@
           <a:p>
             <a:pPr algn="l"/>
             <a:r>
-              <a:rPr lang="en-US" sz="1050" b="1" i="0" dirty="0">
+              <a:rPr lang="en-US" sz="1300" b="1" i="0" dirty="0">
                 <a:solidFill>
                   <a:srgbClr val="1A1A2E"/>
                 </a:solidFill>
@@ -5992,7 +5992,7 @@
           <a:p>
             <a:pPr algn="r"/>
             <a:r>
-              <a:rPr lang="en-US" sz="1050" b="1" i="0" dirty="0">
+              <a:rPr lang="en-US" sz="1300" b="1" i="0" dirty="0">
                 <a:solidFill>
                   <a:srgbClr val="5C068C"/>
                 </a:solidFill>
@@ -6027,13 +6027,13 @@
           <a:p>
             <a:pPr algn="l"/>
             <a:r>
-              <a:rPr lang="en-US" sz="850" b="0" i="0" dirty="0">
+              <a:rPr lang="en-US" sz="1300" b="0" i="0" dirty="0">
                 <a:solidFill>
                   <a:srgbClr val="44546A"/>
                 </a:solidFill>
                 <a:latin typeface="Open Sans" panose="020B0606030504020204" pitchFamily="34" charset="0"/>
               </a:rPr>
-              <a:t>Sources: document ID and exact locator. Fictional training case; not organisational policy or Singapore procurement law.</a:t>
+              <a:t>Sources: document ID and exact locator. Fictional training case.</a:t>
             </a:r>
           </a:p>
         </p:txBody>
@@ -6157,7 +6157,7 @@
           <a:p>
             <a:pPr algn="l"/>
             <a:r>
-              <a:rPr lang="en-US" sz="1000" b="1" i="0" dirty="0">
+              <a:rPr lang="en-US" sz="1300" b="1" i="0" dirty="0">
                 <a:solidFill>
                   <a:srgbClr val="B9C7E6"/>
                 </a:solidFill>
@@ -6192,13 +6192,13 @@
           <a:p>
             <a:pPr algn="l"/>
             <a:r>
-              <a:rPr lang="en-US" sz="850" b="0" i="0" dirty="0">
+              <a:rPr lang="en-US" sz="1300" b="0" i="0" dirty="0">
                 <a:solidFill>
                   <a:srgbClr val="44546A"/>
                 </a:solidFill>
                 <a:latin typeface="Open Sans" panose="020B0606030504020204" pitchFamily="34" charset="0"/>
               </a:rPr>
-              <a:t>Sources: document ID and exact locator. Fictional training case; not organisational policy or Singapore procurement law.</a:t>
+              <a:t>Sources: document ID and exact locator. Fictional training case.</a:t>
             </a:r>
           </a:p>
         </p:txBody>
@@ -6212,6 +6212,1376 @@
 </file>
 
 <file path=ppt/slides/slide5.xml><?xml version="1.0" encoding="utf-8"?>
+<p:sld xmlns:a="http://schemas.openxmlformats.org/drawingml/2006/main" xmlns:r="http://schemas.openxmlformats.org/officeDocument/2006/relationships" xmlns:p="http://schemas.openxmlformats.org/presentationml/2006/main">
+  <p:cSld name="overview">
+    <p:spTree>
+      <p:nvGrpSpPr>
+        <p:cNvPr id="1" name=""/>
+        <p:cNvGrpSpPr/>
+        <p:nvPr/>
+      </p:nvGrpSpPr>
+      <p:grpSpPr>
+        <a:xfrm>
+          <a:off x="0" y="0"/>
+          <a:ext cx="0" cy="0"/>
+          <a:chOff x="0" y="0"/>
+          <a:chExt cx="0" cy="0"/>
+        </a:xfrm>
+      </p:grpSpPr>
+      <p:sp>
+        <p:nvSpPr>
+          <p:cNvPr id="2" name="TITLE"/>
+          <p:cNvSpPr txBox="1"/>
+          <p:nvPr/>
+        </p:nvSpPr>
+        <p:spPr>
+          <a:xfrm>
+            <a:off x="628332" y="339452"/>
+            <a:ext cx="10080000" cy="480000"/>
+          </a:xfrm>
+          <a:prstGeom prst="rect">
+            <a:avLst/>
+          </a:prstGeom>
+          <a:noFill/>
+        </p:spPr>
+        <p:txBody>
+          <a:bodyPr wrap="square" lIns="0" tIns="0" rIns="0" bIns="0" anchor="t">
+            <a:noAutofit/>
+          </a:bodyPr>
+          <a:lstStyle/>
+          <a:p>
+            <a:pPr algn="l"/>
+            <a:r>
+              <a:rPr lang="en-US" sz="2400" b="1" i="0" dirty="0">
+                <a:solidFill>
+                  <a:srgbClr val="003087"/>
+                </a:solidFill>
+                <a:latin typeface="Open Sans" panose="020B0606030504020204" pitchFamily="34" charset="0"/>
+              </a:rPr>
+              <a:t>One clear decision headline</a:t>
+            </a:r>
+          </a:p>
+        </p:txBody>
+      </p:sp>
+      <p:sp>
+        <p:nvSpPr>
+          <p:cNvPr id="3" name="AUDIENCE"/>
+          <p:cNvSpPr txBox="1"/>
+          <p:nvPr/>
+        </p:nvSpPr>
+        <p:spPr>
+          <a:xfrm>
+            <a:off x="628332" y="856028"/>
+            <a:ext cx="10080000" cy="201168"/>
+          </a:xfrm>
+          <a:prstGeom prst="rect">
+            <a:avLst/>
+          </a:prstGeom>
+          <a:noFill/>
+        </p:spPr>
+        <p:txBody>
+          <a:bodyPr wrap="square" lIns="0" tIns="0" rIns="0" bIns="0" anchor="t">
+            <a:noAutofit/>
+          </a:bodyPr>
+          <a:lstStyle/>
+          <a:p>
+            <a:pPr algn="l"/>
+            <a:r>
+              <a:rPr lang="en-US" sz="1300" b="1" i="0" dirty="0">
+                <a:solidFill>
+                  <a:srgbClr val="44546A"/>
+                </a:solidFill>
+                <a:latin typeface="Open Sans" panose="020B0606030504020204" pitchFamily="34" charset="0"/>
+              </a:rPr>
+              <a:t>Audience / decision owner</a:t>
+            </a:r>
+          </a:p>
+        </p:txBody>
+      </p:sp>
+      <p:sp>
+        <p:nvSpPr>
+          <p:cNvPr id="4" name="SUMMARY"/>
+          <p:cNvSpPr txBox="1"/>
+          <p:nvPr/>
+        </p:nvSpPr>
+        <p:spPr>
+          <a:xfrm>
+            <a:off x="628335" y="1185212"/>
+            <a:ext cx="10079999" cy="1188720"/>
+          </a:xfrm>
+          <a:prstGeom prst="rect">
+            <a:avLst/>
+          </a:prstGeom>
+          <a:noFill/>
+        </p:spPr>
+        <p:txBody>
+          <a:bodyPr wrap="square" lIns="0" tIns="0" rIns="0" bIns="0" anchor="t">
+            <a:noAutofit/>
+          </a:bodyPr>
+          <a:lstStyle/>
+          <a:p>
+            <a:pPr algn="l"/>
+            <a:r>
+              <a:rPr lang="en-US" sz="1800" b="0" i="0" dirty="0">
+                <a:solidFill>
+                  <a:srgbClr val="1A1A2E"/>
+                </a:solidFill>
+                <a:latin typeface="Open Sans" panose="020B0606030504020204" pitchFamily="34" charset="0"/>
+              </a:rPr>
+              <a:t>What is being procured, in plain language.</a:t>
+            </a:r>
+          </a:p>
+        </p:txBody>
+      </p:sp>
+      <p:sp>
+        <p:nvSpPr>
+          <p:cNvPr id="5" name="FACT_CARD_1"/>
+          <p:cNvSpPr/>
+          <p:nvPr/>
+        </p:nvSpPr>
+        <p:spPr>
+          <a:xfrm>
+            <a:off x="628335" y="2693972"/>
+            <a:ext cx="2348550" cy="1463040"/>
+          </a:xfrm>
+          <a:prstGeom prst="roundRect">
+            <a:avLst>
+              <a:gd name="adj" fmla="val 8000"/>
+            </a:avLst>
+          </a:prstGeom>
+          <a:solidFill>
+            <a:srgbClr val="F5F7FA"/>
+          </a:solidFill>
+          <a:ln>
+            <a:noFill/>
+          </a:ln>
+        </p:spPr>
+        <p:txBody>
+          <a:bodyPr/>
+          <a:lstStyle/>
+          <a:p>
+            <a:endParaRPr lang="en-US"/>
+          </a:p>
+        </p:txBody>
+      </p:sp>
+      <p:sp>
+        <p:nvSpPr>
+          <p:cNvPr id="6" name="FACT_ACCENT_1"/>
+          <p:cNvSpPr/>
+          <p:nvPr/>
+        </p:nvSpPr>
+        <p:spPr>
+          <a:xfrm>
+            <a:off x="628335" y="2693972"/>
+            <a:ext cx="2348550" cy="73152"/>
+          </a:xfrm>
+          <a:prstGeom prst="rect">
+            <a:avLst/>
+          </a:prstGeom>
+          <a:solidFill>
+            <a:srgbClr val="003087"/>
+          </a:solidFill>
+          <a:ln>
+            <a:noFill/>
+          </a:ln>
+        </p:spPr>
+        <p:txBody>
+          <a:bodyPr/>
+          <a:lstStyle/>
+          <a:p>
+            <a:endParaRPr lang="en-US"/>
+          </a:p>
+        </p:txBody>
+      </p:sp>
+      <p:sp>
+        <p:nvSpPr>
+          <p:cNvPr id="7" name="FACT_LABEL_1"/>
+          <p:cNvSpPr txBox="1"/>
+          <p:nvPr/>
+        </p:nvSpPr>
+        <p:spPr>
+          <a:xfrm>
+            <a:off x="792927" y="2922572"/>
+            <a:ext cx="2019366" cy="274320"/>
+          </a:xfrm>
+          <a:prstGeom prst="rect">
+            <a:avLst/>
+          </a:prstGeom>
+          <a:noFill/>
+        </p:spPr>
+        <p:txBody>
+          <a:bodyPr wrap="square" lIns="0" tIns="0" rIns="0" bIns="0" anchor="t">
+            <a:noAutofit/>
+          </a:bodyPr>
+          <a:lstStyle/>
+          <a:p>
+            <a:pPr algn="l"/>
+            <a:r>
+              <a:rPr lang="en-US" sz="1300" b="1" i="0" dirty="0">
+                <a:solidFill>
+                  <a:srgbClr val="44546A"/>
+                </a:solidFill>
+                <a:latin typeface="Open Sans" panose="020B0606030504020204" pitchFamily="34" charset="0"/>
+              </a:rPr>
+              <a:t>Fact label</a:t>
+            </a:r>
+          </a:p>
+        </p:txBody>
+      </p:sp>
+      <p:sp>
+        <p:nvSpPr>
+          <p:cNvPr id="8" name="FACT_VALUE_1"/>
+          <p:cNvSpPr txBox="1"/>
+          <p:nvPr/>
+        </p:nvSpPr>
+        <p:spPr>
+          <a:xfrm>
+            <a:off x="792927" y="3260900"/>
+            <a:ext cx="2019366" cy="777240"/>
+          </a:xfrm>
+          <a:prstGeom prst="rect">
+            <a:avLst/>
+          </a:prstGeom>
+          <a:noFill/>
+        </p:spPr>
+        <p:txBody>
+          <a:bodyPr wrap="square" lIns="0" tIns="0" rIns="0" bIns="0" anchor="t">
+            <a:noAutofit/>
+          </a:bodyPr>
+          <a:lstStyle/>
+          <a:p>
+            <a:pPr algn="l"/>
+            <a:r>
+              <a:rPr lang="en-US" sz="1800" b="1" i="0" dirty="0">
+                <a:solidFill>
+                  <a:srgbClr val="003087"/>
+                </a:solidFill>
+                <a:latin typeface="Open Sans" panose="020B0606030504020204" pitchFamily="34" charset="0"/>
+              </a:rPr>
+              <a:t>Headline value</a:t>
+            </a:r>
+          </a:p>
+        </p:txBody>
+      </p:sp>
+      <p:sp>
+        <p:nvSpPr>
+          <p:cNvPr id="9" name="FACT_CARD_2"/>
+          <p:cNvSpPr/>
+          <p:nvPr/>
+        </p:nvSpPr>
+        <p:spPr>
+          <a:xfrm>
+            <a:off x="3205485" y="2693972"/>
+            <a:ext cx="2348550" cy="1463040"/>
+          </a:xfrm>
+          <a:prstGeom prst="roundRect">
+            <a:avLst>
+              <a:gd name="adj" fmla="val 8000"/>
+            </a:avLst>
+          </a:prstGeom>
+          <a:solidFill>
+            <a:srgbClr val="F5F7FA"/>
+          </a:solidFill>
+          <a:ln>
+            <a:noFill/>
+          </a:ln>
+        </p:spPr>
+        <p:txBody>
+          <a:bodyPr/>
+          <a:lstStyle/>
+          <a:p>
+            <a:endParaRPr lang="en-US"/>
+          </a:p>
+        </p:txBody>
+      </p:sp>
+      <p:sp>
+        <p:nvSpPr>
+          <p:cNvPr id="10" name="FACT_ACCENT_2"/>
+          <p:cNvSpPr/>
+          <p:nvPr/>
+        </p:nvSpPr>
+        <p:spPr>
+          <a:xfrm>
+            <a:off x="3205485" y="2693972"/>
+            <a:ext cx="2348550" cy="73152"/>
+          </a:xfrm>
+          <a:prstGeom prst="rect">
+            <a:avLst/>
+          </a:prstGeom>
+          <a:solidFill>
+            <a:srgbClr val="003087"/>
+          </a:solidFill>
+          <a:ln>
+            <a:noFill/>
+          </a:ln>
+        </p:spPr>
+        <p:txBody>
+          <a:bodyPr/>
+          <a:lstStyle/>
+          <a:p>
+            <a:endParaRPr lang="en-US"/>
+          </a:p>
+        </p:txBody>
+      </p:sp>
+      <p:sp>
+        <p:nvSpPr>
+          <p:cNvPr id="11" name="FACT_LABEL_2"/>
+          <p:cNvSpPr txBox="1"/>
+          <p:nvPr/>
+        </p:nvSpPr>
+        <p:spPr>
+          <a:xfrm>
+            <a:off x="3370077" y="2922572"/>
+            <a:ext cx="2019366" cy="274320"/>
+          </a:xfrm>
+          <a:prstGeom prst="rect">
+            <a:avLst/>
+          </a:prstGeom>
+          <a:noFill/>
+        </p:spPr>
+        <p:txBody>
+          <a:bodyPr wrap="square" lIns="0" tIns="0" rIns="0" bIns="0" anchor="t">
+            <a:noAutofit/>
+          </a:bodyPr>
+          <a:lstStyle/>
+          <a:p>
+            <a:pPr algn="l"/>
+            <a:r>
+              <a:rPr lang="en-US" sz="1300" b="1" i="0" dirty="0">
+                <a:solidFill>
+                  <a:srgbClr val="44546A"/>
+                </a:solidFill>
+                <a:latin typeface="Open Sans" panose="020B0606030504020204" pitchFamily="34" charset="0"/>
+              </a:rPr>
+              <a:t>Fact label</a:t>
+            </a:r>
+          </a:p>
+        </p:txBody>
+      </p:sp>
+      <p:sp>
+        <p:nvSpPr>
+          <p:cNvPr id="12" name="FACT_VALUE_2"/>
+          <p:cNvSpPr txBox="1"/>
+          <p:nvPr/>
+        </p:nvSpPr>
+        <p:spPr>
+          <a:xfrm>
+            <a:off x="3370077" y="3260900"/>
+            <a:ext cx="2019366" cy="777240"/>
+          </a:xfrm>
+          <a:prstGeom prst="rect">
+            <a:avLst/>
+          </a:prstGeom>
+          <a:noFill/>
+        </p:spPr>
+        <p:txBody>
+          <a:bodyPr wrap="square" lIns="0" tIns="0" rIns="0" bIns="0" anchor="t">
+            <a:noAutofit/>
+          </a:bodyPr>
+          <a:lstStyle/>
+          <a:p>
+            <a:pPr algn="l"/>
+            <a:r>
+              <a:rPr lang="en-US" sz="1800" b="1" i="0" dirty="0">
+                <a:solidFill>
+                  <a:srgbClr val="003087"/>
+                </a:solidFill>
+                <a:latin typeface="Open Sans" panose="020B0606030504020204" pitchFamily="34" charset="0"/>
+              </a:rPr>
+              <a:t>Headline value</a:t>
+            </a:r>
+          </a:p>
+        </p:txBody>
+      </p:sp>
+      <p:sp>
+        <p:nvSpPr>
+          <p:cNvPr id="13" name="FACT_CARD_3"/>
+          <p:cNvSpPr/>
+          <p:nvPr/>
+        </p:nvSpPr>
+        <p:spPr>
+          <a:xfrm>
+            <a:off x="5782635" y="2693972"/>
+            <a:ext cx="2348550" cy="1463040"/>
+          </a:xfrm>
+          <a:prstGeom prst="roundRect">
+            <a:avLst>
+              <a:gd name="adj" fmla="val 8000"/>
+            </a:avLst>
+          </a:prstGeom>
+          <a:solidFill>
+            <a:srgbClr val="F5F7FA"/>
+          </a:solidFill>
+          <a:ln>
+            <a:noFill/>
+          </a:ln>
+        </p:spPr>
+        <p:txBody>
+          <a:bodyPr/>
+          <a:lstStyle/>
+          <a:p>
+            <a:endParaRPr lang="en-US"/>
+          </a:p>
+        </p:txBody>
+      </p:sp>
+      <p:sp>
+        <p:nvSpPr>
+          <p:cNvPr id="14" name="FACT_ACCENT_3"/>
+          <p:cNvSpPr/>
+          <p:nvPr/>
+        </p:nvSpPr>
+        <p:spPr>
+          <a:xfrm>
+            <a:off x="5782635" y="2693972"/>
+            <a:ext cx="2348550" cy="73152"/>
+          </a:xfrm>
+          <a:prstGeom prst="rect">
+            <a:avLst/>
+          </a:prstGeom>
+          <a:solidFill>
+            <a:srgbClr val="003087"/>
+          </a:solidFill>
+          <a:ln>
+            <a:noFill/>
+          </a:ln>
+        </p:spPr>
+        <p:txBody>
+          <a:bodyPr/>
+          <a:lstStyle/>
+          <a:p>
+            <a:endParaRPr lang="en-US"/>
+          </a:p>
+        </p:txBody>
+      </p:sp>
+      <p:sp>
+        <p:nvSpPr>
+          <p:cNvPr id="15" name="FACT_LABEL_3"/>
+          <p:cNvSpPr txBox="1"/>
+          <p:nvPr/>
+        </p:nvSpPr>
+        <p:spPr>
+          <a:xfrm>
+            <a:off x="5947227" y="2922572"/>
+            <a:ext cx="2019366" cy="274320"/>
+          </a:xfrm>
+          <a:prstGeom prst="rect">
+            <a:avLst/>
+          </a:prstGeom>
+          <a:noFill/>
+        </p:spPr>
+        <p:txBody>
+          <a:bodyPr wrap="square" lIns="0" tIns="0" rIns="0" bIns="0" anchor="t">
+            <a:noAutofit/>
+          </a:bodyPr>
+          <a:lstStyle/>
+          <a:p>
+            <a:pPr algn="l"/>
+            <a:r>
+              <a:rPr lang="en-US" sz="1300" b="1" i="0" dirty="0">
+                <a:solidFill>
+                  <a:srgbClr val="44546A"/>
+                </a:solidFill>
+                <a:latin typeface="Open Sans" panose="020B0606030504020204" pitchFamily="34" charset="0"/>
+              </a:rPr>
+              <a:t>Fact label</a:t>
+            </a:r>
+          </a:p>
+        </p:txBody>
+      </p:sp>
+      <p:sp>
+        <p:nvSpPr>
+          <p:cNvPr id="16" name="FACT_VALUE_3"/>
+          <p:cNvSpPr txBox="1"/>
+          <p:nvPr/>
+        </p:nvSpPr>
+        <p:spPr>
+          <a:xfrm>
+            <a:off x="5947227" y="3260900"/>
+            <a:ext cx="2019366" cy="777240"/>
+          </a:xfrm>
+          <a:prstGeom prst="rect">
+            <a:avLst/>
+          </a:prstGeom>
+          <a:noFill/>
+        </p:spPr>
+        <p:txBody>
+          <a:bodyPr wrap="square" lIns="0" tIns="0" rIns="0" bIns="0" anchor="t">
+            <a:noAutofit/>
+          </a:bodyPr>
+          <a:lstStyle/>
+          <a:p>
+            <a:pPr algn="l"/>
+            <a:r>
+              <a:rPr lang="en-US" sz="1800" b="1" i="0" dirty="0">
+                <a:solidFill>
+                  <a:srgbClr val="003087"/>
+                </a:solidFill>
+                <a:latin typeface="Open Sans" panose="020B0606030504020204" pitchFamily="34" charset="0"/>
+              </a:rPr>
+              <a:t>Headline value</a:t>
+            </a:r>
+          </a:p>
+        </p:txBody>
+      </p:sp>
+      <p:sp>
+        <p:nvSpPr>
+          <p:cNvPr id="17" name="FACT_CARD_4"/>
+          <p:cNvSpPr/>
+          <p:nvPr/>
+        </p:nvSpPr>
+        <p:spPr>
+          <a:xfrm>
+            <a:off x="8359784" y="2693972"/>
+            <a:ext cx="2348550" cy="1463040"/>
+          </a:xfrm>
+          <a:prstGeom prst="roundRect">
+            <a:avLst>
+              <a:gd name="adj" fmla="val 8000"/>
+            </a:avLst>
+          </a:prstGeom>
+          <a:solidFill>
+            <a:srgbClr val="F5F7FA"/>
+          </a:solidFill>
+          <a:ln>
+            <a:noFill/>
+          </a:ln>
+        </p:spPr>
+        <p:txBody>
+          <a:bodyPr/>
+          <a:lstStyle/>
+          <a:p>
+            <a:endParaRPr lang="en-US"/>
+          </a:p>
+        </p:txBody>
+      </p:sp>
+      <p:sp>
+        <p:nvSpPr>
+          <p:cNvPr id="18" name="FACT_ACCENT_4"/>
+          <p:cNvSpPr/>
+          <p:nvPr/>
+        </p:nvSpPr>
+        <p:spPr>
+          <a:xfrm>
+            <a:off x="8359784" y="2693972"/>
+            <a:ext cx="2348550" cy="73152"/>
+          </a:xfrm>
+          <a:prstGeom prst="rect">
+            <a:avLst/>
+          </a:prstGeom>
+          <a:solidFill>
+            <a:srgbClr val="003087"/>
+          </a:solidFill>
+          <a:ln>
+            <a:noFill/>
+          </a:ln>
+        </p:spPr>
+        <p:txBody>
+          <a:bodyPr/>
+          <a:lstStyle/>
+          <a:p>
+            <a:endParaRPr lang="en-US"/>
+          </a:p>
+        </p:txBody>
+      </p:sp>
+      <p:sp>
+        <p:nvSpPr>
+          <p:cNvPr id="19" name="FACT_LABEL_4"/>
+          <p:cNvSpPr txBox="1"/>
+          <p:nvPr/>
+        </p:nvSpPr>
+        <p:spPr>
+          <a:xfrm>
+            <a:off x="8524376" y="2922572"/>
+            <a:ext cx="2019366" cy="274320"/>
+          </a:xfrm>
+          <a:prstGeom prst="rect">
+            <a:avLst/>
+          </a:prstGeom>
+          <a:noFill/>
+        </p:spPr>
+        <p:txBody>
+          <a:bodyPr wrap="square" lIns="0" tIns="0" rIns="0" bIns="0" anchor="t">
+            <a:noAutofit/>
+          </a:bodyPr>
+          <a:lstStyle/>
+          <a:p>
+            <a:pPr algn="l"/>
+            <a:r>
+              <a:rPr lang="en-US" sz="1300" b="1" i="0" dirty="0">
+                <a:solidFill>
+                  <a:srgbClr val="44546A"/>
+                </a:solidFill>
+                <a:latin typeface="Open Sans" panose="020B0606030504020204" pitchFamily="34" charset="0"/>
+              </a:rPr>
+              <a:t>Fact label</a:t>
+            </a:r>
+          </a:p>
+        </p:txBody>
+      </p:sp>
+      <p:sp>
+        <p:nvSpPr>
+          <p:cNvPr id="20" name="FACT_VALUE_4"/>
+          <p:cNvSpPr txBox="1"/>
+          <p:nvPr/>
+        </p:nvSpPr>
+        <p:spPr>
+          <a:xfrm>
+            <a:off x="8524376" y="3260900"/>
+            <a:ext cx="2019366" cy="777240"/>
+          </a:xfrm>
+          <a:prstGeom prst="rect">
+            <a:avLst/>
+          </a:prstGeom>
+          <a:noFill/>
+        </p:spPr>
+        <p:txBody>
+          <a:bodyPr wrap="square" lIns="0" tIns="0" rIns="0" bIns="0" anchor="t">
+            <a:noAutofit/>
+          </a:bodyPr>
+          <a:lstStyle/>
+          <a:p>
+            <a:pPr algn="l"/>
+            <a:r>
+              <a:rPr lang="en-US" sz="1800" b="1" i="0" dirty="0">
+                <a:solidFill>
+                  <a:srgbClr val="003087"/>
+                </a:solidFill>
+                <a:latin typeface="Open Sans" panose="020B0606030504020204" pitchFamily="34" charset="0"/>
+              </a:rPr>
+              <a:t>Headline value</a:t>
+            </a:r>
+          </a:p>
+        </p:txBody>
+      </p:sp>
+      <p:sp>
+        <p:nvSpPr>
+          <p:cNvPr id="21" name="SOURCE_NOTES"/>
+          <p:cNvSpPr txBox="1"/>
+          <p:nvPr/>
+        </p:nvSpPr>
+        <p:spPr>
+          <a:xfrm>
+            <a:off x="628335" y="4522772"/>
+            <a:ext cx="10079999" cy="274320"/>
+          </a:xfrm>
+          <a:prstGeom prst="rect">
+            <a:avLst/>
+          </a:prstGeom>
+          <a:noFill/>
+        </p:spPr>
+        <p:txBody>
+          <a:bodyPr wrap="square" lIns="0" tIns="0" rIns="0" bIns="0" anchor="t">
+            <a:noAutofit/>
+          </a:bodyPr>
+          <a:lstStyle/>
+          <a:p>
+            <a:pPr algn="l"/>
+            <a:r>
+              <a:rPr lang="en-US" sz="1300" b="0" i="0" dirty="0">
+                <a:solidFill>
+                  <a:srgbClr val="44546A"/>
+                </a:solidFill>
+                <a:latin typeface="Open Sans" panose="020B0606030504020204" pitchFamily="34" charset="0"/>
+              </a:rPr>
+              <a:t>Sources: document ID and exact locator. Fictional training case.</a:t>
+            </a:r>
+          </a:p>
+        </p:txBody>
+      </p:sp>
+    </p:spTree>
+  </p:cSld>
+  <p:clrMapOvr>
+    <a:masterClrMapping/>
+  </p:clrMapOvr>
+</p:sld>
+</file>
+
+<file path=ppt/slides/slide6.xml><?xml version="1.0" encoding="utf-8"?>
+<p:sld xmlns:a="http://schemas.openxmlformats.org/drawingml/2006/main" xmlns:r="http://schemas.openxmlformats.org/officeDocument/2006/relationships" xmlns:p="http://schemas.openxmlformats.org/presentationml/2006/main">
+  <p:cSld name="overview">
+    <p:spTree>
+      <p:nvGrpSpPr>
+        <p:cNvPr id="1" name=""/>
+        <p:cNvGrpSpPr/>
+        <p:nvPr/>
+      </p:nvGrpSpPr>
+      <p:grpSpPr>
+        <a:xfrm>
+          <a:off x="0" y="0"/>
+          <a:ext cx="0" cy="0"/>
+          <a:chOff x="0" y="0"/>
+          <a:chExt cx="0" cy="0"/>
+        </a:xfrm>
+      </p:grpSpPr>
+      <p:sp>
+        <p:nvSpPr>
+          <p:cNvPr id="2" name="TITLE"/>
+          <p:cNvSpPr txBox="1"/>
+          <p:nvPr/>
+        </p:nvSpPr>
+        <p:spPr>
+          <a:xfrm>
+            <a:off x="628332" y="339452"/>
+            <a:ext cx="10080000" cy="480000"/>
+          </a:xfrm>
+          <a:prstGeom prst="rect">
+            <a:avLst/>
+          </a:prstGeom>
+          <a:noFill/>
+        </p:spPr>
+        <p:txBody>
+          <a:bodyPr wrap="square" lIns="0" tIns="0" rIns="0" bIns="0" anchor="t">
+            <a:noAutofit/>
+          </a:bodyPr>
+          <a:lstStyle/>
+          <a:p>
+            <a:pPr algn="l"/>
+            <a:r>
+              <a:rPr lang="en-US" sz="2400" b="1" i="0" dirty="0">
+                <a:solidFill>
+                  <a:srgbClr val="003087"/>
+                </a:solidFill>
+                <a:latin typeface="Open Sans" panose="020B0606030504020204" pitchFamily="34" charset="0"/>
+              </a:rPr>
+              <a:t>What we are buying: the ARER-300 test platform</a:t>
+            </a:r>
+          </a:p>
+        </p:txBody>
+      </p:sp>
+      <p:sp>
+        <p:nvSpPr>
+          <p:cNvPr id="3" name="AUDIENCE"/>
+          <p:cNvSpPr txBox="1"/>
+          <p:nvPr/>
+        </p:nvSpPr>
+        <p:spPr>
+          <a:xfrm>
+            <a:off x="628332" y="856028"/>
+            <a:ext cx="10080000" cy="201168"/>
+          </a:xfrm>
+          <a:prstGeom prst="rect">
+            <a:avLst/>
+          </a:prstGeom>
+          <a:noFill/>
+        </p:spPr>
+        <p:txBody>
+          <a:bodyPr wrap="square" lIns="0" tIns="0" rIns="0" bIns="0" anchor="t">
+            <a:noAutofit/>
+          </a:bodyPr>
+          <a:lstStyle/>
+          <a:p>
+            <a:pPr algn="l"/>
+            <a:r>
+              <a:rPr lang="en-US" sz="1300" b="1" i="0" dirty="0">
+                <a:solidFill>
+                  <a:srgbClr val="44546A"/>
+                </a:solidFill>
+                <a:latin typeface="Open Sans" panose="020B0606030504020204" pitchFamily="34" charset="0"/>
+              </a:rPr>
+              <a:t>Executive Approval Committee</a:t>
+            </a:r>
+          </a:p>
+        </p:txBody>
+      </p:sp>
+      <p:sp>
+        <p:nvSpPr>
+          <p:cNvPr id="4" name="SUMMARY"/>
+          <p:cNvSpPr txBox="1"/>
+          <p:nvPr/>
+        </p:nvSpPr>
+        <p:spPr>
+          <a:xfrm>
+            <a:off x="628335" y="1185212"/>
+            <a:ext cx="10079999" cy="1188720"/>
+          </a:xfrm>
+          <a:prstGeom prst="rect">
+            <a:avLst/>
+          </a:prstGeom>
+          <a:noFill/>
+        </p:spPr>
+        <p:txBody>
+          <a:bodyPr wrap="square" lIns="0" tIns="0" rIns="0" bIns="0" anchor="t">
+            <a:noAutofit/>
+          </a:bodyPr>
+          <a:lstStyle/>
+          <a:p>
+            <a:pPr algn="l"/>
+            <a:r>
+              <a:rPr lang="en-US" sz="1800" b="0" i="0" dirty="0">
+                <a:solidFill>
+                  <a:srgbClr val="1A1A2E"/>
+                </a:solidFill>
+                <a:latin typeface="Open Sans" panose="020B0606030504020204" pitchFamily="34" charset="0"/>
+              </a:rPr>
+              <a:t>A reliability test chamber that stresses many specimens at once with heat, mechanical load and electrical bias, and records when and how each one fails.</a:t>
+            </a:r>
+          </a:p>
+        </p:txBody>
+      </p:sp>
+      <p:sp>
+        <p:nvSpPr>
+          <p:cNvPr id="5" name="FACT_CARD_1"/>
+          <p:cNvSpPr/>
+          <p:nvPr/>
+        </p:nvSpPr>
+        <p:spPr>
+          <a:xfrm>
+            <a:off x="628335" y="2693972"/>
+            <a:ext cx="2348550" cy="1463040"/>
+          </a:xfrm>
+          <a:prstGeom prst="roundRect">
+            <a:avLst>
+              <a:gd name="adj" fmla="val 8000"/>
+            </a:avLst>
+          </a:prstGeom>
+          <a:solidFill>
+            <a:srgbClr val="F5F7FA"/>
+          </a:solidFill>
+          <a:ln>
+            <a:noFill/>
+          </a:ln>
+        </p:spPr>
+        <p:txBody>
+          <a:bodyPr/>
+          <a:lstStyle/>
+          <a:p>
+            <a:endParaRPr lang="en-US"/>
+          </a:p>
+        </p:txBody>
+      </p:sp>
+      <p:sp>
+        <p:nvSpPr>
+          <p:cNvPr id="6" name="FACT_ACCENT_1"/>
+          <p:cNvSpPr/>
+          <p:nvPr/>
+        </p:nvSpPr>
+        <p:spPr>
+          <a:xfrm>
+            <a:off x="628335" y="2693972"/>
+            <a:ext cx="2348550" cy="73152"/>
+          </a:xfrm>
+          <a:prstGeom prst="rect">
+            <a:avLst/>
+          </a:prstGeom>
+          <a:solidFill>
+            <a:srgbClr val="003087"/>
+          </a:solidFill>
+          <a:ln>
+            <a:noFill/>
+          </a:ln>
+        </p:spPr>
+        <p:txBody>
+          <a:bodyPr/>
+          <a:lstStyle/>
+          <a:p>
+            <a:endParaRPr lang="en-US"/>
+          </a:p>
+        </p:txBody>
+      </p:sp>
+      <p:sp>
+        <p:nvSpPr>
+          <p:cNvPr id="7" name="FACT_LABEL_1"/>
+          <p:cNvSpPr txBox="1"/>
+          <p:nvPr/>
+        </p:nvSpPr>
+        <p:spPr>
+          <a:xfrm>
+            <a:off x="792927" y="2922572"/>
+            <a:ext cx="2019366" cy="274320"/>
+          </a:xfrm>
+          <a:prstGeom prst="rect">
+            <a:avLst/>
+          </a:prstGeom>
+          <a:noFill/>
+        </p:spPr>
+        <p:txBody>
+          <a:bodyPr wrap="square" lIns="0" tIns="0" rIns="0" bIns="0" anchor="t">
+            <a:noAutofit/>
+          </a:bodyPr>
+          <a:lstStyle/>
+          <a:p>
+            <a:pPr algn="l"/>
+            <a:r>
+              <a:rPr lang="en-US" sz="1300" b="1" i="0" dirty="0">
+                <a:solidFill>
+                  <a:srgbClr val="44546A"/>
+                </a:solidFill>
+                <a:latin typeface="Open Sans" panose="020B0606030504020204" pitchFamily="34" charset="0"/>
+              </a:rPr>
+              <a:t>Capacity</a:t>
+            </a:r>
+          </a:p>
+        </p:txBody>
+      </p:sp>
+      <p:sp>
+        <p:nvSpPr>
+          <p:cNvPr id="8" name="FACT_VALUE_1"/>
+          <p:cNvSpPr txBox="1"/>
+          <p:nvPr/>
+        </p:nvSpPr>
+        <p:spPr>
+          <a:xfrm>
+            <a:off x="792927" y="3260900"/>
+            <a:ext cx="2019366" cy="777240"/>
+          </a:xfrm>
+          <a:prstGeom prst="rect">
+            <a:avLst/>
+          </a:prstGeom>
+          <a:noFill/>
+        </p:spPr>
+        <p:txBody>
+          <a:bodyPr wrap="square" lIns="0" tIns="0" rIns="0" bIns="0" anchor="t">
+            <a:noAutofit/>
+          </a:bodyPr>
+          <a:lstStyle/>
+          <a:p>
+            <a:pPr algn="l"/>
+            <a:r>
+              <a:rPr lang="en-US" sz="1800" b="1" i="0" dirty="0">
+                <a:solidFill>
+                  <a:srgbClr val="003087"/>
+                </a:solidFill>
+                <a:latin typeface="Open Sans" panose="020B0606030504020204" pitchFamily="34" charset="0"/>
+              </a:rPr>
+              <a:t>48 specimens in one run</a:t>
+            </a:r>
+          </a:p>
+        </p:txBody>
+      </p:sp>
+      <p:sp>
+        <p:nvSpPr>
+          <p:cNvPr id="9" name="FACT_CARD_2"/>
+          <p:cNvSpPr/>
+          <p:nvPr/>
+        </p:nvSpPr>
+        <p:spPr>
+          <a:xfrm>
+            <a:off x="3205485" y="2693972"/>
+            <a:ext cx="2348550" cy="1463040"/>
+          </a:xfrm>
+          <a:prstGeom prst="roundRect">
+            <a:avLst>
+              <a:gd name="adj" fmla="val 8000"/>
+            </a:avLst>
+          </a:prstGeom>
+          <a:solidFill>
+            <a:srgbClr val="F5F7FA"/>
+          </a:solidFill>
+          <a:ln>
+            <a:noFill/>
+          </a:ln>
+        </p:spPr>
+        <p:txBody>
+          <a:bodyPr/>
+          <a:lstStyle/>
+          <a:p>
+            <a:endParaRPr lang="en-US"/>
+          </a:p>
+        </p:txBody>
+      </p:sp>
+      <p:sp>
+        <p:nvSpPr>
+          <p:cNvPr id="10" name="FACT_ACCENT_2"/>
+          <p:cNvSpPr/>
+          <p:nvPr/>
+        </p:nvSpPr>
+        <p:spPr>
+          <a:xfrm>
+            <a:off x="3205485" y="2693972"/>
+            <a:ext cx="2348550" cy="73152"/>
+          </a:xfrm>
+          <a:prstGeom prst="rect">
+            <a:avLst/>
+          </a:prstGeom>
+          <a:solidFill>
+            <a:srgbClr val="003087"/>
+          </a:solidFill>
+          <a:ln>
+            <a:noFill/>
+          </a:ln>
+        </p:spPr>
+        <p:txBody>
+          <a:bodyPr/>
+          <a:lstStyle/>
+          <a:p>
+            <a:endParaRPr lang="en-US"/>
+          </a:p>
+        </p:txBody>
+      </p:sp>
+      <p:sp>
+        <p:nvSpPr>
+          <p:cNvPr id="11" name="FACT_LABEL_2"/>
+          <p:cNvSpPr txBox="1"/>
+          <p:nvPr/>
+        </p:nvSpPr>
+        <p:spPr>
+          <a:xfrm>
+            <a:off x="3370077" y="2922572"/>
+            <a:ext cx="2019366" cy="274320"/>
+          </a:xfrm>
+          <a:prstGeom prst="rect">
+            <a:avLst/>
+          </a:prstGeom>
+          <a:noFill/>
+        </p:spPr>
+        <p:txBody>
+          <a:bodyPr wrap="square" lIns="0" tIns="0" rIns="0" bIns="0" anchor="t">
+            <a:noAutofit/>
+          </a:bodyPr>
+          <a:lstStyle/>
+          <a:p>
+            <a:pPr algn="l"/>
+            <a:r>
+              <a:rPr lang="en-US" sz="1300" b="1" i="0" dirty="0">
+                <a:solidFill>
+                  <a:srgbClr val="44546A"/>
+                </a:solidFill>
+                <a:latin typeface="Open Sans" panose="020B0606030504020204" pitchFamily="34" charset="0"/>
+              </a:rPr>
+              <a:t>Stress ranges</a:t>
+            </a:r>
+          </a:p>
+        </p:txBody>
+      </p:sp>
+      <p:sp>
+        <p:nvSpPr>
+          <p:cNvPr id="12" name="FACT_VALUE_2"/>
+          <p:cNvSpPr txBox="1"/>
+          <p:nvPr/>
+        </p:nvSpPr>
+        <p:spPr>
+          <a:xfrm>
+            <a:off x="3370077" y="3260900"/>
+            <a:ext cx="2019366" cy="777240"/>
+          </a:xfrm>
+          <a:prstGeom prst="rect">
+            <a:avLst/>
+          </a:prstGeom>
+          <a:noFill/>
+        </p:spPr>
+        <p:txBody>
+          <a:bodyPr wrap="square" lIns="0" tIns="0" rIns="0" bIns="0" anchor="t">
+            <a:noAutofit/>
+          </a:bodyPr>
+          <a:lstStyle/>
+          <a:p>
+            <a:pPr algn="l"/>
+            <a:r>
+              <a:rPr lang="en-US" sz="1800" b="1" i="0" dirty="0">
+                <a:solidFill>
+                  <a:srgbClr val="003087"/>
+                </a:solidFill>
+                <a:latin typeface="Open Sans" panose="020B0606030504020204" pitchFamily="34" charset="0"/>
+              </a:rPr>
+              <a:t>−40 to 125 °C, 500 N, 24 V</a:t>
+            </a:r>
+          </a:p>
+        </p:txBody>
+      </p:sp>
+      <p:sp>
+        <p:nvSpPr>
+          <p:cNvPr id="13" name="FACT_CARD_3"/>
+          <p:cNvSpPr/>
+          <p:nvPr/>
+        </p:nvSpPr>
+        <p:spPr>
+          <a:xfrm>
+            <a:off x="5782635" y="2693972"/>
+            <a:ext cx="2348550" cy="1463040"/>
+          </a:xfrm>
+          <a:prstGeom prst="roundRect">
+            <a:avLst>
+              <a:gd name="adj" fmla="val 8000"/>
+            </a:avLst>
+          </a:prstGeom>
+          <a:solidFill>
+            <a:srgbClr val="F5F7FA"/>
+          </a:solidFill>
+          <a:ln>
+            <a:noFill/>
+          </a:ln>
+        </p:spPr>
+        <p:txBody>
+          <a:bodyPr/>
+          <a:lstStyle/>
+          <a:p>
+            <a:endParaRPr lang="en-US"/>
+          </a:p>
+        </p:txBody>
+      </p:sp>
+      <p:sp>
+        <p:nvSpPr>
+          <p:cNvPr id="14" name="FACT_ACCENT_3"/>
+          <p:cNvSpPr/>
+          <p:nvPr/>
+        </p:nvSpPr>
+        <p:spPr>
+          <a:xfrm>
+            <a:off x="5782635" y="2693972"/>
+            <a:ext cx="2348550" cy="73152"/>
+          </a:xfrm>
+          <a:prstGeom prst="rect">
+            <a:avLst/>
+          </a:prstGeom>
+          <a:solidFill>
+            <a:srgbClr val="003087"/>
+          </a:solidFill>
+          <a:ln>
+            <a:noFill/>
+          </a:ln>
+        </p:spPr>
+        <p:txBody>
+          <a:bodyPr/>
+          <a:lstStyle/>
+          <a:p>
+            <a:endParaRPr lang="en-US"/>
+          </a:p>
+        </p:txBody>
+      </p:sp>
+      <p:sp>
+        <p:nvSpPr>
+          <p:cNvPr id="15" name="FACT_LABEL_3"/>
+          <p:cNvSpPr txBox="1"/>
+          <p:nvPr/>
+        </p:nvSpPr>
+        <p:spPr>
+          <a:xfrm>
+            <a:off x="5947227" y="2922572"/>
+            <a:ext cx="2019366" cy="274320"/>
+          </a:xfrm>
+          <a:prstGeom prst="rect">
+            <a:avLst/>
+          </a:prstGeom>
+          <a:noFill/>
+        </p:spPr>
+        <p:txBody>
+          <a:bodyPr wrap="square" lIns="0" tIns="0" rIns="0" bIns="0" anchor="t">
+            <a:noAutofit/>
+          </a:bodyPr>
+          <a:lstStyle/>
+          <a:p>
+            <a:pPr algn="l"/>
+            <a:r>
+              <a:rPr lang="en-US" sz="1300" b="1" i="0" dirty="0">
+                <a:solidFill>
+                  <a:srgbClr val="44546A"/>
+                </a:solidFill>
+                <a:latin typeface="Open Sans" panose="020B0606030504020204" pitchFamily="34" charset="0"/>
+              </a:rPr>
+              <a:t>Budget ceiling</a:t>
+            </a:r>
+          </a:p>
+        </p:txBody>
+      </p:sp>
+      <p:sp>
+        <p:nvSpPr>
+          <p:cNvPr id="16" name="FACT_VALUE_3"/>
+          <p:cNvSpPr txBox="1"/>
+          <p:nvPr/>
+        </p:nvSpPr>
+        <p:spPr>
+          <a:xfrm>
+            <a:off x="5947227" y="3260900"/>
+            <a:ext cx="2019366" cy="777240"/>
+          </a:xfrm>
+          <a:prstGeom prst="rect">
+            <a:avLst/>
+          </a:prstGeom>
+          <a:noFill/>
+        </p:spPr>
+        <p:txBody>
+          <a:bodyPr wrap="square" lIns="0" tIns="0" rIns="0" bIns="0" anchor="t">
+            <a:noAutofit/>
+          </a:bodyPr>
+          <a:lstStyle/>
+          <a:p>
+            <a:pPr algn="l"/>
+            <a:r>
+              <a:rPr lang="en-US" sz="1800" b="1" i="0" dirty="0">
+                <a:solidFill>
+                  <a:srgbClr val="003087"/>
+                </a:solidFill>
+                <a:latin typeface="Open Sans" panose="020B0606030504020204" pitchFamily="34" charset="0"/>
+              </a:rPr>
+              <a:t>S$450,000 ex GST</a:t>
+            </a:r>
+          </a:p>
+        </p:txBody>
+      </p:sp>
+      <p:sp>
+        <p:nvSpPr>
+          <p:cNvPr id="17" name="FACT_CARD_4"/>
+          <p:cNvSpPr/>
+          <p:nvPr/>
+        </p:nvSpPr>
+        <p:spPr>
+          <a:xfrm>
+            <a:off x="8359784" y="2693972"/>
+            <a:ext cx="2348550" cy="1463040"/>
+          </a:xfrm>
+          <a:prstGeom prst="roundRect">
+            <a:avLst>
+              <a:gd name="adj" fmla="val 8000"/>
+            </a:avLst>
+          </a:prstGeom>
+          <a:solidFill>
+            <a:srgbClr val="F5F7FA"/>
+          </a:solidFill>
+          <a:ln>
+            <a:noFill/>
+          </a:ln>
+        </p:spPr>
+        <p:txBody>
+          <a:bodyPr/>
+          <a:lstStyle/>
+          <a:p>
+            <a:endParaRPr lang="en-US"/>
+          </a:p>
+        </p:txBody>
+      </p:sp>
+      <p:sp>
+        <p:nvSpPr>
+          <p:cNvPr id="18" name="FACT_ACCENT_4"/>
+          <p:cNvSpPr/>
+          <p:nvPr/>
+        </p:nvSpPr>
+        <p:spPr>
+          <a:xfrm>
+            <a:off x="8359784" y="2693972"/>
+            <a:ext cx="2348550" cy="73152"/>
+          </a:xfrm>
+          <a:prstGeom prst="rect">
+            <a:avLst/>
+          </a:prstGeom>
+          <a:solidFill>
+            <a:srgbClr val="003087"/>
+          </a:solidFill>
+          <a:ln>
+            <a:noFill/>
+          </a:ln>
+        </p:spPr>
+        <p:txBody>
+          <a:bodyPr/>
+          <a:lstStyle/>
+          <a:p>
+            <a:endParaRPr lang="en-US"/>
+          </a:p>
+        </p:txBody>
+      </p:sp>
+      <p:sp>
+        <p:nvSpPr>
+          <p:cNvPr id="19" name="FACT_LABEL_4"/>
+          <p:cNvSpPr txBox="1"/>
+          <p:nvPr/>
+        </p:nvSpPr>
+        <p:spPr>
+          <a:xfrm>
+            <a:off x="8524376" y="2922572"/>
+            <a:ext cx="2019366" cy="274320"/>
+          </a:xfrm>
+          <a:prstGeom prst="rect">
+            <a:avLst/>
+          </a:prstGeom>
+          <a:noFill/>
+        </p:spPr>
+        <p:txBody>
+          <a:bodyPr wrap="square" lIns="0" tIns="0" rIns="0" bIns="0" anchor="t">
+            <a:noAutofit/>
+          </a:bodyPr>
+          <a:lstStyle/>
+          <a:p>
+            <a:pPr algn="l"/>
+            <a:r>
+              <a:rPr lang="en-US" sz="1300" b="1" i="0" dirty="0">
+                <a:solidFill>
+                  <a:srgbClr val="44546A"/>
+                </a:solidFill>
+                <a:latin typeface="Open Sans" panose="020B0606030504020204" pitchFamily="34" charset="0"/>
+              </a:rPr>
+              <a:t>In service</a:t>
+            </a:r>
+          </a:p>
+        </p:txBody>
+      </p:sp>
+      <p:sp>
+        <p:nvSpPr>
+          <p:cNvPr id="20" name="FACT_VALUE_4"/>
+          <p:cNvSpPr txBox="1"/>
+          <p:nvPr/>
+        </p:nvSpPr>
+        <p:spPr>
+          <a:xfrm>
+            <a:off x="8524376" y="3260900"/>
+            <a:ext cx="2019366" cy="777240"/>
+          </a:xfrm>
+          <a:prstGeom prst="rect">
+            <a:avLst/>
+          </a:prstGeom>
+          <a:noFill/>
+        </p:spPr>
+        <p:txBody>
+          <a:bodyPr wrap="square" lIns="0" tIns="0" rIns="0" bIns="0" anchor="t">
+            <a:noAutofit/>
+          </a:bodyPr>
+          <a:lstStyle/>
+          <a:p>
+            <a:pPr algn="l"/>
+            <a:r>
+              <a:rPr lang="en-US" sz="1800" b="1" i="0" dirty="0">
+                <a:solidFill>
+                  <a:srgbClr val="003087"/>
+                </a:solidFill>
+                <a:latin typeface="Open Sans" panose="020B0606030504020204" pitchFamily="34" charset="0"/>
+              </a:rPr>
+              <a:t>Jan 2027 to Mar 2030</a:t>
+            </a:r>
+          </a:p>
+        </p:txBody>
+      </p:sp>
+      <p:sp>
+        <p:nvSpPr>
+          <p:cNvPr id="21" name="SOURCE_NOTES"/>
+          <p:cNvSpPr txBox="1"/>
+          <p:nvPr/>
+        </p:nvSpPr>
+        <p:spPr>
+          <a:xfrm>
+            <a:off x="628335" y="4522772"/>
+            <a:ext cx="10079999" cy="274320"/>
+          </a:xfrm>
+          <a:prstGeom prst="rect">
+            <a:avLst/>
+          </a:prstGeom>
+          <a:noFill/>
+        </p:spPr>
+        <p:txBody>
+          <a:bodyPr wrap="square" lIns="0" tIns="0" rIns="0" bIns="0" anchor="t">
+            <a:noAutofit/>
+          </a:bodyPr>
+          <a:lstStyle/>
+          <a:p>
+            <a:pPr algn="l"/>
+            <a:r>
+              <a:rPr lang="en-US" sz="1300" b="0" i="0" dirty="0">
+                <a:solidFill>
+                  <a:srgbClr val="44546A"/>
+                </a:solidFill>
+                <a:latin typeface="Open Sans" panose="020B0606030504020204" pitchFamily="34" charset="0"/>
+              </a:rPr>
+              <a:t>Sources: N/A. Fictional training case.</a:t>
+            </a:r>
+          </a:p>
+        </p:txBody>
+      </p:sp>
+    </p:spTree>
+  </p:cSld>
+  <p:clrMapOvr>
+    <a:masterClrMapping/>
+  </p:clrMapOvr>
+</p:sld>
+</file>
+
+<file path=ppt/slides/slide7.xml><?xml version="1.0" encoding="utf-8"?>
 <p:sld xmlns:a="http://schemas.openxmlformats.org/drawingml/2006/main" xmlns:r="http://schemas.openxmlformats.org/officeDocument/2006/relationships" xmlns:p="http://schemas.openxmlformats.org/presentationml/2006/main">
   <p:cSld name="context">
     <p:spTree>
@@ -6287,7 +7657,7 @@
           <a:p>
             <a:pPr algn="l"/>
             <a:r>
-              <a:rPr lang="en-US" sz="1000" b="1" i="0" dirty="0">
+              <a:rPr lang="en-US" sz="1300" b="1" i="0" dirty="0">
                 <a:solidFill>
                   <a:srgbClr val="44546A"/>
                 </a:solidFill>
@@ -6328,7 +7698,7 @@
                 </a:solidFill>
                 <a:latin typeface="Open Sans" panose="020B0606030504020204" pitchFamily="34" charset="0"/>
               </a:rPr>
-              <a:t>The ARER-300 tender (RFQ-ARER-26-014) closed 28 Aug 2026 with five bids. Mandatory gates M1-M7 must all pass before any weighted score counts, so the committee needs the eligible leader, not simply the highest raw score.</a:t>
+              <a:t>The ARER-300 tender (RFQ-ARER-26-014) closed 28 Aug 2026 with five bids.</a:t>
             </a:r>
           </a:p>
         </p:txBody>
@@ -6357,7 +7727,7 @@
           <a:p>
             <a:pPr algn="l"/>
             <a:r>
-              <a:rPr lang="en-US" sz="1150" b="1" i="0" dirty="0">
+              <a:rPr lang="en-US" sz="1300" b="1" i="0" dirty="0">
                 <a:solidFill>
                   <a:srgbClr val="003087"/>
                 </a:solidFill>
@@ -6392,7 +7762,7 @@
           <a:p>
             <a:pPr algn="l"/>
             <a:r>
-              <a:rPr lang="en-US" sz="1150" b="1" i="0" dirty="0">
+              <a:rPr lang="en-US" sz="1300" b="1" i="0" dirty="0">
                 <a:solidFill>
                   <a:srgbClr val="003087"/>
                 </a:solidFill>
@@ -6427,7 +7797,7 @@
           <a:p>
             <a:pPr algn="l"/>
             <a:r>
-              <a:rPr lang="en-US" sz="950" b="0" i="0" dirty="0">
+              <a:rPr lang="en-US" sz="1300" b="0" i="0" dirty="0">
                 <a:solidFill>
                   <a:srgbClr val="1A1A2E"/>
                 </a:solidFill>
@@ -6462,7 +7832,7 @@
           <a:p>
             <a:pPr algn="l"/>
             <a:r>
-              <a:rPr lang="en-US" sz="950" b="0" i="0" dirty="0">
+              <a:rPr lang="en-US" sz="1300" b="0" i="0" dirty="0">
                 <a:solidFill>
                   <a:srgbClr val="1A1A2E"/>
                 </a:solidFill>
@@ -6497,7 +7867,7 @@
           <a:p>
             <a:pPr algn="l"/>
             <a:r>
-              <a:rPr lang="en-US" sz="950" b="0" i="0" dirty="0">
+              <a:rPr lang="en-US" sz="1300" b="0" i="0" dirty="0">
                 <a:solidFill>
                   <a:srgbClr val="1A1A2E"/>
                 </a:solidFill>
@@ -6532,7 +7902,7 @@
           <a:p>
             <a:pPr algn="l"/>
             <a:r>
-              <a:rPr lang="en-US" sz="950" b="0" i="0" dirty="0">
+              <a:rPr lang="en-US" sz="1300" b="0" i="0" dirty="0">
                 <a:solidFill>
                   <a:srgbClr val="1A1A2E"/>
                 </a:solidFill>
@@ -6567,7 +7937,7 @@
           <a:p>
             <a:pPr algn="l"/>
             <a:r>
-              <a:rPr lang="en-US" sz="950" b="0" i="0" dirty="0">
+              <a:rPr lang="en-US" sz="1300" b="0" i="0" dirty="0">
                 <a:solidFill>
                   <a:srgbClr val="1A1A2E"/>
                 </a:solidFill>
@@ -6602,7 +7972,7 @@
           <a:p>
             <a:pPr algn="l"/>
             <a:r>
-              <a:rPr lang="en-US" sz="950" b="0" i="0" dirty="0">
+              <a:rPr lang="en-US" sz="1300" b="0" i="0" dirty="0">
                 <a:solidFill>
                   <a:srgbClr val="1A1A2E"/>
                 </a:solidFill>
@@ -6637,7 +8007,7 @@
           <a:p>
             <a:pPr algn="l"/>
             <a:r>
-              <a:rPr lang="en-US" sz="950" b="0" i="0" dirty="0">
+              <a:rPr lang="en-US" sz="1300" b="0" i="0" dirty="0">
                 <a:solidFill>
                   <a:srgbClr val="1A1A2E"/>
                 </a:solidFill>
@@ -6701,7 +8071,7 @@
           <a:p>
             <a:pPr algn="l"/>
             <a:r>
-              <a:rPr lang="en-US" sz="1050" b="1" i="0" dirty="0">
+              <a:rPr lang="en-US" sz="1300" b="1" i="0" dirty="0">
                 <a:solidFill>
                   <a:srgbClr val="1A1A2E"/>
                 </a:solidFill>
@@ -6736,7 +8106,7 @@
           <a:p>
             <a:pPr algn="r"/>
             <a:r>
-              <a:rPr lang="en-US" sz="1050" b="1" i="0" dirty="0">
+              <a:rPr lang="en-US" sz="1300" b="1" i="0" dirty="0">
                 <a:solidFill>
                   <a:srgbClr val="5C068C"/>
                 </a:solidFill>
@@ -6800,7 +8170,7 @@
           <a:p>
             <a:pPr algn="l"/>
             <a:r>
-              <a:rPr lang="en-US" sz="1050" b="1" i="0" dirty="0">
+              <a:rPr lang="en-US" sz="1300" b="1" i="0" dirty="0">
                 <a:solidFill>
                   <a:srgbClr val="1A1A2E"/>
                 </a:solidFill>
@@ -6835,7 +8205,7 @@
           <a:p>
             <a:pPr algn="r"/>
             <a:r>
-              <a:rPr lang="en-US" sz="1050" b="1" i="0" dirty="0">
+              <a:rPr lang="en-US" sz="1300" b="1" i="0" dirty="0">
                 <a:solidFill>
                   <a:srgbClr val="5C068C"/>
                 </a:solidFill>
@@ -6899,7 +8269,7 @@
           <a:p>
             <a:pPr algn="l"/>
             <a:r>
-              <a:rPr lang="en-US" sz="1050" b="1" i="0" dirty="0">
+              <a:rPr lang="en-US" sz="1300" b="1" i="0" dirty="0">
                 <a:solidFill>
                   <a:srgbClr val="1A1A2E"/>
                 </a:solidFill>
@@ -6934,7 +8304,7 @@
           <a:p>
             <a:pPr algn="r"/>
             <a:r>
-              <a:rPr lang="en-US" sz="1050" b="1" i="0" dirty="0">
+              <a:rPr lang="en-US" sz="1300" b="1" i="0" dirty="0">
                 <a:solidFill>
                   <a:srgbClr val="5C068C"/>
                 </a:solidFill>
@@ -6998,7 +8368,7 @@
           <a:p>
             <a:pPr algn="l"/>
             <a:r>
-              <a:rPr lang="en-US" sz="1050" b="1" i="0" dirty="0">
+              <a:rPr lang="en-US" sz="1300" b="1" i="0" dirty="0">
                 <a:solidFill>
                   <a:srgbClr val="1A1A2E"/>
                 </a:solidFill>
@@ -7033,7 +8403,7 @@
           <a:p>
             <a:pPr algn="r"/>
             <a:r>
-              <a:rPr lang="en-US" sz="1050" b="1" i="0" dirty="0">
+              <a:rPr lang="en-US" sz="1300" b="1" i="0" dirty="0">
                 <a:solidFill>
                   <a:srgbClr val="5C068C"/>
                 </a:solidFill>
@@ -7068,13 +8438,13 @@
           <a:p>
             <a:pPr algn="l"/>
             <a:r>
-              <a:rPr lang="en-US" sz="850" b="0" i="0" dirty="0">
+              <a:rPr lang="en-US" sz="1300" b="0" i="0" dirty="0">
                 <a:solidFill>
                   <a:srgbClr val="44546A"/>
                 </a:solidFill>
                 <a:latin typeface="Open Sans" panose="020B0606030504020204" pitchFamily="34" charset="0"/>
               </a:rPr>
-              <a:t>Sources: RFQ-02 M1-M7; NST-05 service term; EMAIL-02 service clarification thread; EVAL-01 summary scores; EVAL-02 proposal comparison. Fictional training case.</a:t>
+              <a:t>Sources: N/A. Fictional training case.</a:t>
             </a:r>
           </a:p>
         </p:txBody>
@@ -7087,7 +8457,7 @@
 </p:sld>
 </file>
 
-<file path=ppt/slides/slide6.xml><?xml version="1.0" encoding="utf-8"?>
+<file path=ppt/slides/slide8.xml><?xml version="1.0" encoding="utf-8"?>
 <p:sld xmlns:a="http://schemas.openxmlformats.org/drawingml/2006/main" xmlns:r="http://schemas.openxmlformats.org/officeDocument/2006/relationships" xmlns:p="http://schemas.openxmlformats.org/presentationml/2006/main">
   <p:cSld name="gate_focus">
     <p:spTree>
@@ -7163,7 +8533,7 @@
           <a:p>
             <a:pPr algn="l"/>
             <a:r>
-              <a:rPr lang="en-US" sz="1000" b="1" i="0" dirty="0">
+              <a:rPr lang="en-US" sz="1300" b="1" i="0" dirty="0">
                 <a:solidFill>
                   <a:srgbClr val="44546A"/>
                 </a:solidFill>
@@ -7264,7 +8634,7 @@
                 </a:solidFill>
                 <a:latin typeface="Open Sans" panose="020B0606030504020204" pitchFamily="34" charset="0"/>
               </a:rPr>
-              <a:t>Three of five bids pass all seven mandatory gates; two fail and are dismissed</a:t>
+              <a:t>Recommendation: select Northstar, the top-scoring bid at S$348,000 ex GST</a:t>
             </a:r>
           </a:p>
         </p:txBody>
@@ -7293,7 +8663,7 @@
           <a:p>
             <a:pPr algn="l"/>
             <a:r>
-              <a:rPr lang="en-US" sz="1250" b="1" i="0" dirty="0">
+              <a:rPr lang="en-US" sz="1300" b="1" i="0" dirty="0">
                 <a:solidFill>
                   <a:srgbClr val="003087"/>
                 </a:solidFill>
@@ -7328,7 +8698,7 @@
           <a:p>
             <a:pPr algn="l"/>
             <a:r>
-              <a:rPr lang="en-US" sz="1250" b="1" i="0" dirty="0">
+              <a:rPr lang="en-US" sz="1300" b="1" i="0" dirty="0">
                 <a:solidFill>
                   <a:srgbClr val="003087"/>
                 </a:solidFill>
@@ -7392,7 +8762,7 @@
           <a:p>
             <a:pPr algn="l"/>
             <a:r>
-              <a:rPr lang="en-US" sz="850" b="1" i="0" dirty="0">
+              <a:rPr lang="en-US" sz="1300" b="1" i="0" dirty="0">
                 <a:solidFill>
                   <a:srgbClr val="44546A"/>
                 </a:solidFill>
@@ -7427,7 +8797,7 @@
           <a:p>
             <a:pPr algn="l"/>
             <a:r>
-              <a:rPr lang="en-US" sz="850" b="1" i="0" dirty="0">
+              <a:rPr lang="en-US" sz="1300" b="1" i="0" dirty="0">
                 <a:solidFill>
                   <a:srgbClr val="44546A"/>
                 </a:solidFill>
@@ -7462,7 +8832,7 @@
           <a:p>
             <a:pPr algn="l"/>
             <a:r>
-              <a:rPr lang="en-US" sz="850" b="1" i="0" dirty="0">
+              <a:rPr lang="en-US" sz="1300" b="1" i="0" dirty="0">
                 <a:solidFill>
                   <a:srgbClr val="44546A"/>
                 </a:solidFill>
@@ -7526,7 +8896,7 @@
           <a:p>
             <a:pPr algn="l"/>
             <a:r>
-              <a:rPr lang="en-US" sz="1050" b="1" i="0" dirty="0">
+              <a:rPr lang="en-US" sz="1300" b="1" i="0" dirty="0">
                 <a:solidFill>
                   <a:srgbClr val="1A1A2E"/>
                 </a:solidFill>
@@ -7561,9 +8931,9 @@
           <a:p>
             <a:pPr algn="l"/>
             <a:r>
-              <a:rPr lang="en-US" sz="850" b="1" i="0" dirty="0">
-                <a:solidFill>
-                  <a:srgbClr val="44546A"/>
+              <a:rPr lang="en-US" sz="1300" b="1" i="0" dirty="0">
+                <a:solidFill>
+                  <a:srgbClr val="1E8449"/>
                 </a:solidFill>
                 <a:latin typeface="Open Sans" panose="020B0606030504020204" pitchFamily="34" charset="0"/>
               </a:rPr>
@@ -7596,7 +8966,7 @@
           <a:p>
             <a:pPr algn="l"/>
             <a:r>
-              <a:rPr lang="en-US" sz="900" b="0" i="0" dirty="0">
+              <a:rPr lang="en-US" sz="1300" b="0" i="0" dirty="0">
                 <a:solidFill>
                   <a:srgbClr val="44546A"/>
                 </a:solidFill>
@@ -7660,7 +9030,7 @@
           <a:p>
             <a:pPr algn="l"/>
             <a:r>
-              <a:rPr lang="en-US" sz="1050" b="1" i="0" dirty="0">
+              <a:rPr lang="en-US" sz="1300" b="1" i="0" dirty="0">
                 <a:solidFill>
                   <a:srgbClr val="1A1A2E"/>
                 </a:solidFill>
@@ -7695,9 +9065,9 @@
           <a:p>
             <a:pPr algn="l"/>
             <a:r>
-              <a:rPr lang="en-US" sz="850" b="1" i="0" dirty="0">
-                <a:solidFill>
-                  <a:srgbClr val="44546A"/>
+              <a:rPr lang="en-US" sz="1300" b="1" i="0" dirty="0">
+                <a:solidFill>
+                  <a:srgbClr val="1E8449"/>
                 </a:solidFill>
                 <a:latin typeface="Open Sans" panose="020B0606030504020204" pitchFamily="34" charset="0"/>
               </a:rPr>
@@ -7730,7 +9100,7 @@
           <a:p>
             <a:pPr algn="l"/>
             <a:r>
-              <a:rPr lang="en-US" sz="900" b="0" i="0" dirty="0">
+              <a:rPr lang="en-US" sz="1300" b="0" i="0" dirty="0">
                 <a:solidFill>
                   <a:srgbClr val="44546A"/>
                 </a:solidFill>
@@ -7794,7 +9164,7 @@
           <a:p>
             <a:pPr algn="l"/>
             <a:r>
-              <a:rPr lang="en-US" sz="1050" b="1" i="0" dirty="0">
+              <a:rPr lang="en-US" sz="1300" b="1" i="0" dirty="0">
                 <a:solidFill>
                   <a:srgbClr val="1A1A2E"/>
                 </a:solidFill>
@@ -7829,9 +9199,9 @@
           <a:p>
             <a:pPr algn="l"/>
             <a:r>
-              <a:rPr lang="en-US" sz="850" b="1" i="0" dirty="0">
-                <a:solidFill>
-                  <a:srgbClr val="44546A"/>
+              <a:rPr lang="en-US" sz="1300" b="1" i="0" dirty="0">
+                <a:solidFill>
+                  <a:srgbClr val="1E8449"/>
                 </a:solidFill>
                 <a:latin typeface="Open Sans" panose="020B0606030504020204" pitchFamily="34" charset="0"/>
               </a:rPr>
@@ -7864,7 +9234,7 @@
           <a:p>
             <a:pPr algn="l"/>
             <a:r>
-              <a:rPr lang="en-US" sz="900" b="0" i="0" dirty="0">
+              <a:rPr lang="en-US" sz="1300" b="0" i="0" dirty="0">
                 <a:solidFill>
                   <a:srgbClr val="44546A"/>
                 </a:solidFill>
@@ -7928,7 +9298,7 @@
           <a:p>
             <a:pPr algn="l"/>
             <a:r>
-              <a:rPr lang="en-US" sz="1050" b="1" i="0" dirty="0">
+              <a:rPr lang="en-US" sz="1300" b="1" i="0" dirty="0">
                 <a:solidFill>
                   <a:srgbClr val="1A1A2E"/>
                 </a:solidFill>
@@ -7963,9 +9333,9 @@
           <a:p>
             <a:pPr algn="l"/>
             <a:r>
-              <a:rPr lang="en-US" sz="850" b="1" i="0" dirty="0">
-                <a:solidFill>
-                  <a:srgbClr val="44546A"/>
+              <a:rPr lang="en-US" sz="1300" b="1" i="0" dirty="0">
+                <a:solidFill>
+                  <a:srgbClr val="DA291C"/>
                 </a:solidFill>
                 <a:latin typeface="Open Sans" panose="020B0606030504020204" pitchFamily="34" charset="0"/>
               </a:rPr>
@@ -7998,7 +9368,7 @@
           <a:p>
             <a:pPr algn="l"/>
             <a:r>
-              <a:rPr lang="en-US" sz="900" b="0" i="0" dirty="0">
+              <a:rPr lang="en-US" sz="1300" b="0" i="0" dirty="0">
                 <a:solidFill>
                   <a:srgbClr val="44546A"/>
                 </a:solidFill>
@@ -8062,7 +9432,7 @@
           <a:p>
             <a:pPr algn="l"/>
             <a:r>
-              <a:rPr lang="en-US" sz="1050" b="1" i="0" dirty="0">
+              <a:rPr lang="en-US" sz="1300" b="1" i="0" dirty="0">
                 <a:solidFill>
                   <a:srgbClr val="1A1A2E"/>
                 </a:solidFill>
@@ -8097,9 +9467,9 @@
           <a:p>
             <a:pPr algn="l"/>
             <a:r>
-              <a:rPr lang="en-US" sz="850" b="1" i="0" dirty="0">
-                <a:solidFill>
-                  <a:srgbClr val="44546A"/>
+              <a:rPr lang="en-US" sz="1300" b="1" i="0" dirty="0">
+                <a:solidFill>
+                  <a:srgbClr val="DA291C"/>
                 </a:solidFill>
                 <a:latin typeface="Open Sans" panose="020B0606030504020204" pitchFamily="34" charset="0"/>
               </a:rPr>
@@ -8132,7 +9502,7 @@
           <a:p>
             <a:pPr algn="l"/>
             <a:r>
-              <a:rPr lang="en-US" sz="900" b="0" i="0" dirty="0">
+              <a:rPr lang="en-US" sz="1300" b="0" i="0" dirty="0">
                 <a:solidFill>
                   <a:srgbClr val="44546A"/>
                 </a:solidFill>
@@ -8198,7 +9568,7 @@
           <a:p>
             <a:pPr algn="l"/>
             <a:r>
-              <a:rPr lang="en-US" sz="1050" b="1" i="0" dirty="0">
+              <a:rPr lang="en-US" sz="1300" b="1" i="0" dirty="0">
                 <a:solidFill>
                   <a:srgbClr val="1A1A2E"/>
                 </a:solidFill>
@@ -8295,7 +9665,7 @@
           <a:p>
             <a:pPr algn="r"/>
             <a:r>
-              <a:rPr lang="en-US" sz="1050" b="1" i="0" dirty="0">
+              <a:rPr lang="en-US" sz="1300" b="1" i="0" dirty="0">
                 <a:solidFill>
                   <a:srgbClr val="1A1A2E"/>
                 </a:solidFill>
@@ -8330,7 +9700,7 @@
           <a:p>
             <a:pPr algn="l"/>
             <a:r>
-              <a:rPr lang="en-US" sz="850" b="0" i="0" dirty="0">
+              <a:rPr lang="en-US" sz="1300" b="0" i="0" dirty="0">
                 <a:solidFill>
                   <a:srgbClr val="44546A"/>
                 </a:solidFill>
@@ -8365,7 +9735,7 @@
           <a:p>
             <a:pPr algn="l"/>
             <a:r>
-              <a:rPr lang="en-US" sz="1050" b="1" i="0" dirty="0">
+              <a:rPr lang="en-US" sz="1300" b="1" i="0" dirty="0">
                 <a:solidFill>
                   <a:srgbClr val="1A1A2E"/>
                 </a:solidFill>
@@ -8462,7 +9832,7 @@
           <a:p>
             <a:pPr algn="r"/>
             <a:r>
-              <a:rPr lang="en-US" sz="1050" b="1" i="0" dirty="0">
+              <a:rPr lang="en-US" sz="1300" b="1" i="0" dirty="0">
                 <a:solidFill>
                   <a:srgbClr val="1A1A2E"/>
                 </a:solidFill>
@@ -8497,7 +9867,7 @@
           <a:p>
             <a:pPr algn="l"/>
             <a:r>
-              <a:rPr lang="en-US" sz="850" b="0" i="0" dirty="0">
+              <a:rPr lang="en-US" sz="1300" b="0" i="0" dirty="0">
                 <a:solidFill>
                   <a:srgbClr val="44546A"/>
                 </a:solidFill>
@@ -8532,7 +9902,7 @@
           <a:p>
             <a:pPr algn="l"/>
             <a:r>
-              <a:rPr lang="en-US" sz="1050" b="1" i="0" dirty="0">
+              <a:rPr lang="en-US" sz="1300" b="1" i="0" dirty="0">
                 <a:solidFill>
                   <a:srgbClr val="1A1A2E"/>
                 </a:solidFill>
@@ -8629,7 +9999,7 @@
           <a:p>
             <a:pPr algn="r"/>
             <a:r>
-              <a:rPr lang="en-US" sz="1050" b="1" i="0" dirty="0">
+              <a:rPr lang="en-US" sz="1300" b="1" i="0" dirty="0">
                 <a:solidFill>
                   <a:srgbClr val="1A1A2E"/>
                 </a:solidFill>
@@ -8664,7 +10034,7 @@
           <a:p>
             <a:pPr algn="l"/>
             <a:r>
-              <a:rPr lang="en-US" sz="850" b="0" i="0" dirty="0">
+              <a:rPr lang="en-US" sz="1300" b="0" i="0" dirty="0">
                 <a:solidFill>
                   <a:srgbClr val="44546A"/>
                 </a:solidFill>
@@ -8683,8 +10053,8 @@
         </p:nvSpPr>
         <p:spPr>
           <a:xfrm>
-            <a:off x="629336" y="5013096"/>
-            <a:ext cx="10914963" cy="530352"/>
+            <a:off x="0" y="0"/>
+            <a:ext cx="1" cy="1"/>
           </a:xfrm>
           <a:prstGeom prst="roundRect">
             <a:avLst>
@@ -8736,7 +10106,7 @@
                 </a:solidFill>
                 <a:latin typeface="Open Sans" panose="020B0606030504020204" pitchFamily="34" charset="0"/>
               </a:rPr>
-              <a:t>Score only the three compliant bids before recommending an award</a:t>
+              <a:t/>
             </a:r>
           </a:p>
         </p:txBody>
@@ -8765,1710 +10135,13 @@
           <a:p>
             <a:pPr algn="l"/>
             <a:r>
-              <a:rPr lang="en-US" sz="850" b="0" i="0" dirty="0">
+              <a:rPr lang="en-US" sz="1300" b="0" i="0" dirty="0">
                 <a:solidFill>
                   <a:srgbClr val="44546A"/>
                 </a:solidFill>
                 <a:latin typeface="Open Sans" panose="020B0606030504020204" pitchFamily="34" charset="0"/>
               </a:rPr>
-              <a:t>Sources: RFQ-02 M1-M7; NST-05 service term; EMAIL-02 service clarification thread; EVAL-01 summary scores; EVAL-02 proposal comparison. Fictional training case.</a:t>
-            </a:r>
-          </a:p>
-        </p:txBody>
-      </p:sp>
-    </p:spTree>
-  </p:cSld>
-  <p:clrMapOvr>
-    <a:masterClrMapping/>
-  </p:clrMapOvr>
-</p:sld>
-</file>
-
-<file path=ppt/slides/slide7.xml><?xml version="1.0" encoding="utf-8"?>
-<p:sld xmlns:a="http://schemas.openxmlformats.org/drawingml/2006/main" xmlns:r="http://schemas.openxmlformats.org/officeDocument/2006/relationships" xmlns:p="http://schemas.openxmlformats.org/presentationml/2006/main">
-  <p:cSld name="decision_summary">
-    <p:spTree>
-      <p:nvGrpSpPr>
-        <p:cNvPr id="1" name=""/>
-        <p:cNvGrpSpPr/>
-        <p:nvPr/>
-      </p:nvGrpSpPr>
-      <p:grpSpPr>
-        <a:xfrm>
-          <a:off x="0" y="0"/>
-          <a:ext cx="0" cy="0"/>
-          <a:chOff x="0" y="0"/>
-          <a:chExt cx="0" cy="0"/>
-        </a:xfrm>
-      </p:grpSpPr>
-      <p:sp>
-        <p:nvSpPr>
-          <p:cNvPr id="2" name="TITLE"/>
-          <p:cNvSpPr txBox="1"/>
-          <p:nvPr/>
-        </p:nvSpPr>
-        <p:spPr>
-          <a:xfrm>
-            <a:off x="629336" y="336000"/>
-            <a:ext cx="10914963" cy="480000"/>
-          </a:xfrm>
-          <a:prstGeom prst="rect">
-            <a:avLst/>
-          </a:prstGeom>
-          <a:noFill/>
-        </p:spPr>
-        <p:txBody>
-          <a:bodyPr wrap="square" lIns="0" tIns="0" rIns="0" bIns="0" anchor="t">
-            <a:noAutofit/>
-          </a:bodyPr>
-          <a:lstStyle/>
-          <a:p>
-            <a:pPr algn="l"/>
-            <a:r>
-              <a:rPr lang="en-US" sz="2400" b="1" i="0" dirty="0">
-                <a:solidFill>
-                  <a:srgbClr val="003087"/>
-                </a:solidFill>
-                <a:latin typeface="Open Sans" panose="020B0606030504020204" pitchFamily="34" charset="0"/>
-              </a:rPr>
-              <a:t>Select Northstar for the ARER-300 platform</a:t>
-            </a:r>
-          </a:p>
-        </p:txBody>
-      </p:sp>
-      <p:sp>
-        <p:nvSpPr>
-          <p:cNvPr id="3" name="AUDIENCE"/>
-          <p:cNvSpPr txBox="1"/>
-          <p:nvPr/>
-        </p:nvSpPr>
-        <p:spPr>
-          <a:xfrm>
-            <a:off x="629336" y="852576"/>
-            <a:ext cx="10914963" cy="201168"/>
-          </a:xfrm>
-          <a:prstGeom prst="rect">
-            <a:avLst/>
-          </a:prstGeom>
-          <a:noFill/>
-        </p:spPr>
-        <p:txBody>
-          <a:bodyPr wrap="square" lIns="0" tIns="0" rIns="0" bIns="0" anchor="t">
-            <a:noAutofit/>
-          </a:bodyPr>
-          <a:lstStyle/>
-          <a:p>
-            <a:pPr algn="l"/>
-            <a:r>
-              <a:rPr lang="en-US" sz="1000" b="1" i="0" dirty="0">
-                <a:solidFill>
-                  <a:srgbClr val="44546A"/>
-                </a:solidFill>
-                <a:latin typeface="Open Sans" panose="020B0606030504020204" pitchFamily="34" charset="0"/>
-              </a:rPr>
-              <a:t>Executive Approval Committee</a:t>
-            </a:r>
-          </a:p>
-        </p:txBody>
-      </p:sp>
-      <p:sp>
-        <p:nvSpPr>
-          <p:cNvPr id="4" name="RECOMMENDATION_PANEL"/>
-          <p:cNvSpPr/>
-          <p:nvPr/>
-        </p:nvSpPr>
-        <p:spPr>
-          <a:xfrm>
-            <a:off x="629336" y="1090320"/>
-            <a:ext cx="10914963" cy="566928"/>
-          </a:xfrm>
-          <a:prstGeom prst="roundRect">
-            <a:avLst>
-              <a:gd name="adj" fmla="val 8000"/>
-            </a:avLst>
-          </a:prstGeom>
-          <a:solidFill>
-            <a:srgbClr val="E7E6E6"/>
-          </a:solidFill>
-          <a:ln>
-            <a:noFill/>
-          </a:ln>
-        </p:spPr>
-        <p:txBody>
-          <a:bodyPr/>
-          <a:lstStyle/>
-          <a:p>
-            <a:endParaRPr lang="en-US"/>
-          </a:p>
-        </p:txBody>
-      </p:sp>
-      <p:sp>
-        <p:nvSpPr>
-          <p:cNvPr id="5" name="RECOMMENDATION_ACCENT"/>
-          <p:cNvSpPr/>
-          <p:nvPr/>
-        </p:nvSpPr>
-        <p:spPr>
-          <a:xfrm>
-            <a:off x="629336" y="1090320"/>
-            <a:ext cx="82296" cy="566928"/>
-          </a:xfrm>
-          <a:prstGeom prst="rect">
-            <a:avLst/>
-          </a:prstGeom>
-          <a:solidFill>
-            <a:srgbClr val="003087"/>
-          </a:solidFill>
-          <a:ln>
-            <a:noFill/>
-          </a:ln>
-        </p:spPr>
-        <p:txBody>
-          <a:bodyPr/>
-          <a:lstStyle/>
-          <a:p>
-            <a:endParaRPr lang="en-US"/>
-          </a:p>
-        </p:txBody>
-      </p:sp>
-      <p:sp>
-        <p:nvSpPr>
-          <p:cNvPr id="6" name="RECOMMENDATION"/>
-          <p:cNvSpPr txBox="1"/>
-          <p:nvPr/>
-        </p:nvSpPr>
-        <p:spPr>
-          <a:xfrm>
-            <a:off x="830504" y="1163472"/>
-            <a:ext cx="10549203" cy="420624"/>
-          </a:xfrm>
-          <a:prstGeom prst="rect">
-            <a:avLst/>
-          </a:prstGeom>
-          <a:noFill/>
-        </p:spPr>
-        <p:txBody>
-          <a:bodyPr wrap="square" lIns="0" tIns="0" rIns="0" bIns="0" anchor="ctr">
-            <a:noAutofit/>
-          </a:bodyPr>
-          <a:lstStyle/>
-          <a:p>
-            <a:pPr algn="l"/>
-            <a:r>
-              <a:rPr lang="en-US" sz="1500" b="1" i="0" dirty="0">
-                <a:solidFill>
-                  <a:srgbClr val="1A1A2E"/>
-                </a:solidFill>
-                <a:latin typeface="Open Sans" panose="020B0606030504020204" pitchFamily="34" charset="0"/>
-              </a:rPr>
-              <a:t>Northstar leads the evaluation and meets all gates</a:t>
-            </a:r>
-          </a:p>
-        </p:txBody>
-      </p:sp>
-      <p:sp>
-        <p:nvSpPr>
-          <p:cNvPr id="7" name="GATE_TABLE"/>
-          <p:cNvSpPr txBox="1"/>
-          <p:nvPr/>
-        </p:nvSpPr>
-        <p:spPr>
-          <a:xfrm>
-            <a:off x="629336" y="1858416"/>
-            <a:ext cx="5457482" cy="274320"/>
-          </a:xfrm>
-          <a:prstGeom prst="rect">
-            <a:avLst/>
-          </a:prstGeom>
-          <a:noFill/>
-        </p:spPr>
-        <p:txBody>
-          <a:bodyPr wrap="square" lIns="0" tIns="0" rIns="0" bIns="0" anchor="t">
-            <a:noAutofit/>
-          </a:bodyPr>
-          <a:lstStyle/>
-          <a:p>
-            <a:pPr algn="l"/>
-            <a:r>
-              <a:rPr lang="en-US" sz="1250" b="1" i="0" dirty="0">
-                <a:solidFill>
-                  <a:srgbClr val="003087"/>
-                </a:solidFill>
-                <a:latin typeface="Open Sans" panose="020B0606030504020204" pitchFamily="34" charset="0"/>
-              </a:rPr>
-              <a:t>MANDATORY COMPLIANCE</a:t>
-            </a:r>
-          </a:p>
-        </p:txBody>
-      </p:sp>
-      <p:sp>
-        <p:nvSpPr>
-          <p:cNvPr id="8" name="COMPARISON_CHART"/>
-          <p:cNvSpPr txBox="1"/>
-          <p:nvPr/>
-        </p:nvSpPr>
-        <p:spPr>
-          <a:xfrm>
-            <a:off x="6315418" y="1858416"/>
-            <a:ext cx="5228881" cy="274320"/>
-          </a:xfrm>
-          <a:prstGeom prst="rect">
-            <a:avLst/>
-          </a:prstGeom>
-          <a:noFill/>
-        </p:spPr>
-        <p:txBody>
-          <a:bodyPr wrap="square" lIns="0" tIns="0" rIns="0" bIns="0" anchor="t">
-            <a:noAutofit/>
-          </a:bodyPr>
-          <a:lstStyle/>
-          <a:p>
-            <a:pPr algn="l"/>
-            <a:r>
-              <a:rPr lang="en-US" sz="1250" b="1" i="0" dirty="0">
-                <a:solidFill>
-                  <a:srgbClr val="003087"/>
-                </a:solidFill>
-                <a:latin typeface="Open Sans" panose="020B0606030504020204" pitchFamily="34" charset="0"/>
-              </a:rPr>
-              <a:t>SCORES AFTER GATE</a:t>
-            </a:r>
-          </a:p>
-        </p:txBody>
-      </p:sp>
-      <p:sp>
-        <p:nvSpPr>
-          <p:cNvPr id="9" name="GATE_HEADER_BG"/>
-          <p:cNvSpPr/>
-          <p:nvPr/>
-        </p:nvSpPr>
-        <p:spPr>
-          <a:xfrm>
-            <a:off x="629336" y="2187600"/>
-            <a:ext cx="5457482" cy="237744"/>
-          </a:xfrm>
-          <a:prstGeom prst="rect">
-            <a:avLst/>
-          </a:prstGeom>
-          <a:solidFill>
-            <a:srgbClr val="E7E6E6"/>
-          </a:solidFill>
-          <a:ln>
-            <a:noFill/>
-          </a:ln>
-        </p:spPr>
-        <p:txBody>
-          <a:bodyPr/>
-          <a:lstStyle/>
-          <a:p>
-            <a:endParaRPr lang="en-US"/>
-          </a:p>
-        </p:txBody>
-      </p:sp>
-      <p:sp>
-        <p:nvSpPr>
-          <p:cNvPr id="10" name="GATE_VENDOR_HEADER"/>
-          <p:cNvSpPr txBox="1"/>
-          <p:nvPr/>
-        </p:nvSpPr>
-        <p:spPr>
-          <a:xfrm>
-            <a:off x="739064" y="2215032"/>
-            <a:ext cx="1528095" cy="182880"/>
-          </a:xfrm>
-          <a:prstGeom prst="rect">
-            <a:avLst/>
-          </a:prstGeom>
-          <a:noFill/>
-        </p:spPr>
-        <p:txBody>
-          <a:bodyPr wrap="square" lIns="0" tIns="0" rIns="0" bIns="0" anchor="t">
-            <a:noAutofit/>
-          </a:bodyPr>
-          <a:lstStyle/>
-          <a:p>
-            <a:pPr algn="l"/>
-            <a:r>
-              <a:rPr lang="en-US" sz="850" b="1" i="0" dirty="0">
-                <a:solidFill>
-                  <a:srgbClr val="44546A"/>
-                </a:solidFill>
-                <a:latin typeface="Open Sans" panose="020B0606030504020204" pitchFamily="34" charset="0"/>
-              </a:rPr>
-              <a:t>VENDOR</a:t>
-            </a:r>
-          </a:p>
-        </p:txBody>
-      </p:sp>
-      <p:sp>
-        <p:nvSpPr>
-          <p:cNvPr id="11" name="GATE_STATUS_HEADER"/>
-          <p:cNvSpPr txBox="1"/>
-          <p:nvPr/>
-        </p:nvSpPr>
-        <p:spPr>
-          <a:xfrm>
-            <a:off x="2266581" y="2215032"/>
-            <a:ext cx="545748" cy="182880"/>
-          </a:xfrm>
-          <a:prstGeom prst="rect">
-            <a:avLst/>
-          </a:prstGeom>
-          <a:noFill/>
-        </p:spPr>
-        <p:txBody>
-          <a:bodyPr wrap="square" lIns="0" tIns="0" rIns="0" bIns="0" anchor="t">
-            <a:noAutofit/>
-          </a:bodyPr>
-          <a:lstStyle/>
-          <a:p>
-            <a:pPr algn="l"/>
-            <a:r>
-              <a:rPr lang="en-US" sz="850" b="1" i="0" dirty="0">
-                <a:solidFill>
-                  <a:srgbClr val="44546A"/>
-                </a:solidFill>
-                <a:latin typeface="Open Sans" panose="020B0606030504020204" pitchFamily="34" charset="0"/>
-              </a:rPr>
-              <a:t>GATE</a:t>
-            </a:r>
-          </a:p>
-        </p:txBody>
-      </p:sp>
-      <p:sp>
-        <p:nvSpPr>
-          <p:cNvPr id="12" name="GATE_REASON_HEADER"/>
-          <p:cNvSpPr txBox="1"/>
-          <p:nvPr/>
-        </p:nvSpPr>
-        <p:spPr>
-          <a:xfrm>
-            <a:off x="2921478" y="2215032"/>
-            <a:ext cx="3165340" cy="182880"/>
-          </a:xfrm>
-          <a:prstGeom prst="rect">
-            <a:avLst/>
-          </a:prstGeom>
-          <a:noFill/>
-        </p:spPr>
-        <p:txBody>
-          <a:bodyPr wrap="square" lIns="0" tIns="0" rIns="0" bIns="0" anchor="t">
-            <a:noAutofit/>
-          </a:bodyPr>
-          <a:lstStyle/>
-          <a:p>
-            <a:pPr algn="l"/>
-            <a:r>
-              <a:rPr lang="en-US" sz="850" b="1" i="0" dirty="0">
-                <a:solidFill>
-                  <a:srgbClr val="44546A"/>
-                </a:solidFill>
-                <a:latin typeface="Open Sans" panose="020B0606030504020204" pitchFamily="34" charset="0"/>
-              </a:rPr>
-              <a:t>DECISIVE BASIS</a:t>
-            </a:r>
-          </a:p>
-        </p:txBody>
-      </p:sp>
-      <p:sp>
-        <p:nvSpPr>
-          <p:cNvPr id="13" name="GATE_ROW_1_BG"/>
-          <p:cNvSpPr/>
-          <p:nvPr/>
-        </p:nvSpPr>
-        <p:spPr>
-          <a:xfrm>
-            <a:off x="629336" y="2471064"/>
-            <a:ext cx="5457482" cy="457200"/>
-          </a:xfrm>
-          <a:prstGeom prst="rect">
-            <a:avLst/>
-          </a:prstGeom>
-          <a:solidFill>
-            <a:srgbClr val="FFFFFF"/>
-          </a:solidFill>
-          <a:ln>
-            <a:noFill/>
-          </a:ln>
-        </p:spPr>
-        <p:txBody>
-          <a:bodyPr/>
-          <a:lstStyle/>
-          <a:p>
-            <a:endParaRPr lang="en-US"/>
-          </a:p>
-        </p:txBody>
-      </p:sp>
-      <p:sp>
-        <p:nvSpPr>
-          <p:cNvPr id="14" name="GATE_VENDOR_1"/>
-          <p:cNvSpPr txBox="1"/>
-          <p:nvPr/>
-        </p:nvSpPr>
-        <p:spPr>
-          <a:xfrm>
-            <a:off x="739064" y="2516784"/>
-            <a:ext cx="1418367" cy="274320"/>
-          </a:xfrm>
-          <a:prstGeom prst="rect">
-            <a:avLst/>
-          </a:prstGeom>
-          <a:noFill/>
-        </p:spPr>
-        <p:txBody>
-          <a:bodyPr wrap="square" lIns="0" tIns="0" rIns="0" bIns="0" anchor="t">
-            <a:noAutofit/>
-          </a:bodyPr>
-          <a:lstStyle/>
-          <a:p>
-            <a:pPr algn="l"/>
-            <a:r>
-              <a:rPr lang="en-US" sz="1050" b="1" i="0" dirty="0">
-                <a:solidFill>
-                  <a:srgbClr val="1A1A2E"/>
-                </a:solidFill>
-                <a:latin typeface="Open Sans" panose="020B0606030504020204" pitchFamily="34" charset="0"/>
-              </a:rPr>
-              <a:t>Northstar</a:t>
-            </a:r>
-          </a:p>
-        </p:txBody>
-      </p:sp>
-      <p:sp>
-        <p:nvSpPr>
-          <p:cNvPr id="15" name="GATE_STATUS_1"/>
-          <p:cNvSpPr txBox="1"/>
-          <p:nvPr/>
-        </p:nvSpPr>
-        <p:spPr>
-          <a:xfrm>
-            <a:off x="2266581" y="2516784"/>
-            <a:ext cx="545748" cy="274320"/>
-          </a:xfrm>
-          <a:prstGeom prst="rect">
-            <a:avLst/>
-          </a:prstGeom>
-          <a:noFill/>
-        </p:spPr>
-        <p:txBody>
-          <a:bodyPr wrap="square" lIns="0" tIns="0" rIns="0" bIns="0" anchor="t">
-            <a:noAutofit/>
-          </a:bodyPr>
-          <a:lstStyle/>
-          <a:p>
-            <a:pPr algn="l"/>
-            <a:r>
-              <a:rPr lang="en-US" sz="850" b="1" i="0" dirty="0">
-                <a:solidFill>
-                  <a:srgbClr val="44546A"/>
-                </a:solidFill>
-                <a:latin typeface="Open Sans" panose="020B0606030504020204" pitchFamily="34" charset="0"/>
-              </a:rPr>
-              <a:t>PASS</a:t>
-            </a:r>
-          </a:p>
-        </p:txBody>
-      </p:sp>
-      <p:sp>
-        <p:nvSpPr>
-          <p:cNvPr id="16" name="GATE_REASON_1"/>
-          <p:cNvSpPr txBox="1"/>
-          <p:nvPr/>
-        </p:nvSpPr>
-        <p:spPr>
-          <a:xfrm>
-            <a:off x="2921478" y="2516784"/>
-            <a:ext cx="3165340" cy="274320"/>
-          </a:xfrm>
-          <a:prstGeom prst="rect">
-            <a:avLst/>
-          </a:prstGeom>
-          <a:noFill/>
-        </p:spPr>
-        <p:txBody>
-          <a:bodyPr wrap="square" lIns="0" tIns="0" rIns="0" bIns="0" anchor="t">
-            <a:noAutofit/>
-          </a:bodyPr>
-          <a:lstStyle/>
-          <a:p>
-            <a:pPr algn="l"/>
-            <a:r>
-              <a:rPr lang="en-US" sz="900" b="0" i="0" dirty="0">
-                <a:solidFill>
-                  <a:srgbClr val="44546A"/>
-                </a:solidFill>
-                <a:latin typeface="Open Sans" panose="020B0606030504020204" pitchFamily="34" charset="0"/>
-              </a:rPr>
-              <a:t>M1-M7 satisfied</a:t>
-            </a:r>
-          </a:p>
-        </p:txBody>
-      </p:sp>
-      <p:sp>
-        <p:nvSpPr>
-          <p:cNvPr id="17" name="GATE_ROW_2_BG"/>
-          <p:cNvSpPr/>
-          <p:nvPr/>
-        </p:nvSpPr>
-        <p:spPr>
-          <a:xfrm>
-            <a:off x="629336" y="2946552"/>
-            <a:ext cx="5457482" cy="457200"/>
-          </a:xfrm>
-          <a:prstGeom prst="rect">
-            <a:avLst/>
-          </a:prstGeom>
-          <a:solidFill>
-            <a:srgbClr val="F5F7FA"/>
-          </a:solidFill>
-          <a:ln>
-            <a:noFill/>
-          </a:ln>
-        </p:spPr>
-        <p:txBody>
-          <a:bodyPr/>
-          <a:lstStyle/>
-          <a:p>
-            <a:endParaRPr lang="en-US"/>
-          </a:p>
-        </p:txBody>
-      </p:sp>
-      <p:sp>
-        <p:nvSpPr>
-          <p:cNvPr id="18" name="GATE_VENDOR_2"/>
-          <p:cNvSpPr txBox="1"/>
-          <p:nvPr/>
-        </p:nvSpPr>
-        <p:spPr>
-          <a:xfrm>
-            <a:off x="739064" y="2992272"/>
-            <a:ext cx="1418367" cy="274320"/>
-          </a:xfrm>
-          <a:prstGeom prst="rect">
-            <a:avLst/>
-          </a:prstGeom>
-          <a:noFill/>
-        </p:spPr>
-        <p:txBody>
-          <a:bodyPr wrap="square" lIns="0" tIns="0" rIns="0" bIns="0" anchor="t">
-            <a:noAutofit/>
-          </a:bodyPr>
-          <a:lstStyle/>
-          <a:p>
-            <a:pPr algn="l"/>
-            <a:r>
-              <a:rPr lang="en-US" sz="1050" b="1" i="0" dirty="0">
-                <a:solidFill>
-                  <a:srgbClr val="1A1A2E"/>
-                </a:solidFill>
-                <a:latin typeface="Open Sans" panose="020B0606030504020204" pitchFamily="34" charset="0"/>
-              </a:rPr>
-              <a:t>Meridian</a:t>
-            </a:r>
-          </a:p>
-        </p:txBody>
-      </p:sp>
-      <p:sp>
-        <p:nvSpPr>
-          <p:cNvPr id="19" name="GATE_STATUS_2"/>
-          <p:cNvSpPr txBox="1"/>
-          <p:nvPr/>
-        </p:nvSpPr>
-        <p:spPr>
-          <a:xfrm>
-            <a:off x="2266581" y="2992272"/>
-            <a:ext cx="545748" cy="274320"/>
-          </a:xfrm>
-          <a:prstGeom prst="rect">
-            <a:avLst/>
-          </a:prstGeom>
-          <a:noFill/>
-        </p:spPr>
-        <p:txBody>
-          <a:bodyPr wrap="square" lIns="0" tIns="0" rIns="0" bIns="0" anchor="t">
-            <a:noAutofit/>
-          </a:bodyPr>
-          <a:lstStyle/>
-          <a:p>
-            <a:pPr algn="l"/>
-            <a:r>
-              <a:rPr lang="en-US" sz="850" b="1" i="0" dirty="0">
-                <a:solidFill>
-                  <a:srgbClr val="44546A"/>
-                </a:solidFill>
-                <a:latin typeface="Open Sans" panose="020B0606030504020204" pitchFamily="34" charset="0"/>
-              </a:rPr>
-              <a:t>PASS</a:t>
-            </a:r>
-          </a:p>
-        </p:txBody>
-      </p:sp>
-      <p:sp>
-        <p:nvSpPr>
-          <p:cNvPr id="20" name="GATE_REASON_2"/>
-          <p:cNvSpPr txBox="1"/>
-          <p:nvPr/>
-        </p:nvSpPr>
-        <p:spPr>
-          <a:xfrm>
-            <a:off x="2921478" y="2992272"/>
-            <a:ext cx="3165340" cy="274320"/>
-          </a:xfrm>
-          <a:prstGeom prst="rect">
-            <a:avLst/>
-          </a:prstGeom>
-          <a:noFill/>
-        </p:spPr>
-        <p:txBody>
-          <a:bodyPr wrap="square" lIns="0" tIns="0" rIns="0" bIns="0" anchor="t">
-            <a:noAutofit/>
-          </a:bodyPr>
-          <a:lstStyle/>
-          <a:p>
-            <a:pPr algn="l"/>
-            <a:r>
-              <a:rPr lang="en-US" sz="900" b="0" i="0" dirty="0">
-                <a:solidFill>
-                  <a:srgbClr val="44546A"/>
-                </a:solidFill>
-                <a:latin typeface="Open Sans" panose="020B0606030504020204" pitchFamily="34" charset="0"/>
-              </a:rPr>
-              <a:t>M1-M7 satisfied</a:t>
-            </a:r>
-          </a:p>
-        </p:txBody>
-      </p:sp>
-      <p:sp>
-        <p:nvSpPr>
-          <p:cNvPr id="21" name="GATE_ROW_3_BG"/>
-          <p:cNvSpPr/>
-          <p:nvPr/>
-        </p:nvSpPr>
-        <p:spPr>
-          <a:xfrm>
-            <a:off x="629336" y="3422040"/>
-            <a:ext cx="5457482" cy="457200"/>
-          </a:xfrm>
-          <a:prstGeom prst="rect">
-            <a:avLst/>
-          </a:prstGeom>
-          <a:solidFill>
-            <a:srgbClr val="FFFFFF"/>
-          </a:solidFill>
-          <a:ln>
-            <a:noFill/>
-          </a:ln>
-        </p:spPr>
-        <p:txBody>
-          <a:bodyPr/>
-          <a:lstStyle/>
-          <a:p>
-            <a:endParaRPr lang="en-US"/>
-          </a:p>
-        </p:txBody>
-      </p:sp>
-      <p:sp>
-        <p:nvSpPr>
-          <p:cNvPr id="22" name="GATE_VENDOR_3"/>
-          <p:cNvSpPr txBox="1"/>
-          <p:nvPr/>
-        </p:nvSpPr>
-        <p:spPr>
-          <a:xfrm>
-            <a:off x="739064" y="3467760"/>
-            <a:ext cx="1418367" cy="274320"/>
-          </a:xfrm>
-          <a:prstGeom prst="rect">
-            <a:avLst/>
-          </a:prstGeom>
-          <a:noFill/>
-        </p:spPr>
-        <p:txBody>
-          <a:bodyPr wrap="square" lIns="0" tIns="0" rIns="0" bIns="0" anchor="t">
-            <a:noAutofit/>
-          </a:bodyPr>
-          <a:lstStyle/>
-          <a:p>
-            <a:pPr algn="l"/>
-            <a:r>
-              <a:rPr lang="en-US" sz="1050" b="1" i="0" dirty="0">
-                <a:solidFill>
-                  <a:srgbClr val="1A1A2E"/>
-                </a:solidFill>
-                <a:latin typeface="Open Sans" panose="020B0606030504020204" pitchFamily="34" charset="0"/>
-              </a:rPr>
-              <a:t>Helix</a:t>
-            </a:r>
-          </a:p>
-        </p:txBody>
-      </p:sp>
-      <p:sp>
-        <p:nvSpPr>
-          <p:cNvPr id="23" name="GATE_STATUS_3"/>
-          <p:cNvSpPr txBox="1"/>
-          <p:nvPr/>
-        </p:nvSpPr>
-        <p:spPr>
-          <a:xfrm>
-            <a:off x="2266581" y="3467760"/>
-            <a:ext cx="545748" cy="274320"/>
-          </a:xfrm>
-          <a:prstGeom prst="rect">
-            <a:avLst/>
-          </a:prstGeom>
-          <a:noFill/>
-        </p:spPr>
-        <p:txBody>
-          <a:bodyPr wrap="square" lIns="0" tIns="0" rIns="0" bIns="0" anchor="t">
-            <a:noAutofit/>
-          </a:bodyPr>
-          <a:lstStyle/>
-          <a:p>
-            <a:pPr algn="l"/>
-            <a:r>
-              <a:rPr lang="en-US" sz="850" b="1" i="0" dirty="0">
-                <a:solidFill>
-                  <a:srgbClr val="44546A"/>
-                </a:solidFill>
-                <a:latin typeface="Open Sans" panose="020B0606030504020204" pitchFamily="34" charset="0"/>
-              </a:rPr>
-              <a:t>PASS</a:t>
-            </a:r>
-          </a:p>
-        </p:txBody>
-      </p:sp>
-      <p:sp>
-        <p:nvSpPr>
-          <p:cNvPr id="24" name="GATE_REASON_3"/>
-          <p:cNvSpPr txBox="1"/>
-          <p:nvPr/>
-        </p:nvSpPr>
-        <p:spPr>
-          <a:xfrm>
-            <a:off x="2921478" y="3467760"/>
-            <a:ext cx="3165340" cy="274320"/>
-          </a:xfrm>
-          <a:prstGeom prst="rect">
-            <a:avLst/>
-          </a:prstGeom>
-          <a:noFill/>
-        </p:spPr>
-        <p:txBody>
-          <a:bodyPr wrap="square" lIns="0" tIns="0" rIns="0" bIns="0" anchor="t">
-            <a:noAutofit/>
-          </a:bodyPr>
-          <a:lstStyle/>
-          <a:p>
-            <a:pPr algn="l"/>
-            <a:r>
-              <a:rPr lang="en-US" sz="900" b="0" i="0" dirty="0">
-                <a:solidFill>
-                  <a:srgbClr val="44546A"/>
-                </a:solidFill>
-                <a:latin typeface="Open Sans" panose="020B0606030504020204" pitchFamily="34" charset="0"/>
-              </a:rPr>
-              <a:t>M1-M7 satisfied</a:t>
-            </a:r>
-          </a:p>
-        </p:txBody>
-      </p:sp>
-      <p:sp>
-        <p:nvSpPr>
-          <p:cNvPr id="25" name="GATE_ROW_4_BG"/>
-          <p:cNvSpPr/>
-          <p:nvPr/>
-        </p:nvSpPr>
-        <p:spPr>
-          <a:xfrm>
-            <a:off x="629336" y="3897528"/>
-            <a:ext cx="5457482" cy="457200"/>
-          </a:xfrm>
-          <a:prstGeom prst="rect">
-            <a:avLst/>
-          </a:prstGeom>
-          <a:solidFill>
-            <a:srgbClr val="F5F7FA"/>
-          </a:solidFill>
-          <a:ln>
-            <a:noFill/>
-          </a:ln>
-        </p:spPr>
-        <p:txBody>
-          <a:bodyPr/>
-          <a:lstStyle/>
-          <a:p>
-            <a:endParaRPr lang="en-US"/>
-          </a:p>
-        </p:txBody>
-      </p:sp>
-      <p:sp>
-        <p:nvSpPr>
-          <p:cNvPr id="26" name="GATE_VENDOR_4"/>
-          <p:cNvSpPr txBox="1"/>
-          <p:nvPr/>
-        </p:nvSpPr>
-        <p:spPr>
-          <a:xfrm>
-            <a:off x="739064" y="3943248"/>
-            <a:ext cx="1418367" cy="274320"/>
-          </a:xfrm>
-          <a:prstGeom prst="rect">
-            <a:avLst/>
-          </a:prstGeom>
-          <a:noFill/>
-        </p:spPr>
-        <p:txBody>
-          <a:bodyPr wrap="square" lIns="0" tIns="0" rIns="0" bIns="0" anchor="t">
-            <a:noAutofit/>
-          </a:bodyPr>
-          <a:lstStyle/>
-          <a:p>
-            <a:pPr algn="l"/>
-            <a:r>
-              <a:rPr lang="en-US" sz="1050" b="1" i="0" dirty="0">
-                <a:solidFill>
-                  <a:srgbClr val="1A1A2E"/>
-                </a:solidFill>
-                <a:latin typeface="Open Sans" panose="020B0606030504020204" pitchFamily="34" charset="0"/>
-              </a:rPr>
-              <a:t/>
-            </a:r>
-          </a:p>
-        </p:txBody>
-      </p:sp>
-      <p:sp>
-        <p:nvSpPr>
-          <p:cNvPr id="27" name="GATE_STATUS_4"/>
-          <p:cNvSpPr txBox="1"/>
-          <p:nvPr/>
-        </p:nvSpPr>
-        <p:spPr>
-          <a:xfrm>
-            <a:off x="2266581" y="3943248"/>
-            <a:ext cx="545748" cy="274320"/>
-          </a:xfrm>
-          <a:prstGeom prst="rect">
-            <a:avLst/>
-          </a:prstGeom>
-          <a:noFill/>
-        </p:spPr>
-        <p:txBody>
-          <a:bodyPr wrap="square" lIns="0" tIns="0" rIns="0" bIns="0" anchor="t">
-            <a:noAutofit/>
-          </a:bodyPr>
-          <a:lstStyle/>
-          <a:p>
-            <a:pPr algn="l"/>
-            <a:r>
-              <a:rPr lang="en-US" sz="850" b="1" i="0" dirty="0">
-                <a:solidFill>
-                  <a:srgbClr val="44546A"/>
-                </a:solidFill>
-                <a:latin typeface="Open Sans" panose="020B0606030504020204" pitchFamily="34" charset="0"/>
-              </a:rPr>
-              <a:t/>
-            </a:r>
-          </a:p>
-        </p:txBody>
-      </p:sp>
-      <p:sp>
-        <p:nvSpPr>
-          <p:cNvPr id="28" name="GATE_REASON_4"/>
-          <p:cNvSpPr txBox="1"/>
-          <p:nvPr/>
-        </p:nvSpPr>
-        <p:spPr>
-          <a:xfrm>
-            <a:off x="2921478" y="3943248"/>
-            <a:ext cx="3165340" cy="274320"/>
-          </a:xfrm>
-          <a:prstGeom prst="rect">
-            <a:avLst/>
-          </a:prstGeom>
-          <a:noFill/>
-        </p:spPr>
-        <p:txBody>
-          <a:bodyPr wrap="square" lIns="0" tIns="0" rIns="0" bIns="0" anchor="t">
-            <a:noAutofit/>
-          </a:bodyPr>
-          <a:lstStyle/>
-          <a:p>
-            <a:pPr algn="l"/>
-            <a:r>
-              <a:rPr lang="en-US" sz="900" b="0" i="0" dirty="0">
-                <a:solidFill>
-                  <a:srgbClr val="44546A"/>
-                </a:solidFill>
-                <a:latin typeface="Open Sans" panose="020B0606030504020204" pitchFamily="34" charset="0"/>
-              </a:rPr>
-              <a:t/>
-            </a:r>
-          </a:p>
-        </p:txBody>
-      </p:sp>
-      <p:sp>
-        <p:nvSpPr>
-          <p:cNvPr id="29" name="GATE_ROW_5_BG"/>
-          <p:cNvSpPr/>
-          <p:nvPr/>
-        </p:nvSpPr>
-        <p:spPr>
-          <a:xfrm>
-            <a:off x="629336" y="4373016"/>
-            <a:ext cx="5457482" cy="457200"/>
-          </a:xfrm>
-          <a:prstGeom prst="rect">
-            <a:avLst/>
-          </a:prstGeom>
-          <a:solidFill>
-            <a:srgbClr val="FFFFFF"/>
-          </a:solidFill>
-          <a:ln>
-            <a:noFill/>
-          </a:ln>
-        </p:spPr>
-        <p:txBody>
-          <a:bodyPr/>
-          <a:lstStyle/>
-          <a:p>
-            <a:endParaRPr lang="en-US"/>
-          </a:p>
-        </p:txBody>
-      </p:sp>
-      <p:sp>
-        <p:nvSpPr>
-          <p:cNvPr id="30" name="GATE_VENDOR_5"/>
-          <p:cNvSpPr txBox="1"/>
-          <p:nvPr/>
-        </p:nvSpPr>
-        <p:spPr>
-          <a:xfrm>
-            <a:off x="739064" y="4418736"/>
-            <a:ext cx="1418367" cy="274320"/>
-          </a:xfrm>
-          <a:prstGeom prst="rect">
-            <a:avLst/>
-          </a:prstGeom>
-          <a:noFill/>
-        </p:spPr>
-        <p:txBody>
-          <a:bodyPr wrap="square" lIns="0" tIns="0" rIns="0" bIns="0" anchor="t">
-            <a:noAutofit/>
-          </a:bodyPr>
-          <a:lstStyle/>
-          <a:p>
-            <a:pPr algn="l"/>
-            <a:r>
-              <a:rPr lang="en-US" sz="1050" b="1" i="0" dirty="0">
-                <a:solidFill>
-                  <a:srgbClr val="1A1A2E"/>
-                </a:solidFill>
-                <a:latin typeface="Open Sans" panose="020B0606030504020204" pitchFamily="34" charset="0"/>
-              </a:rPr>
-              <a:t/>
-            </a:r>
-          </a:p>
-        </p:txBody>
-      </p:sp>
-      <p:sp>
-        <p:nvSpPr>
-          <p:cNvPr id="31" name="GATE_STATUS_5"/>
-          <p:cNvSpPr txBox="1"/>
-          <p:nvPr/>
-        </p:nvSpPr>
-        <p:spPr>
-          <a:xfrm>
-            <a:off x="2266581" y="4418736"/>
-            <a:ext cx="545748" cy="274320"/>
-          </a:xfrm>
-          <a:prstGeom prst="rect">
-            <a:avLst/>
-          </a:prstGeom>
-          <a:noFill/>
-        </p:spPr>
-        <p:txBody>
-          <a:bodyPr wrap="square" lIns="0" tIns="0" rIns="0" bIns="0" anchor="t">
-            <a:noAutofit/>
-          </a:bodyPr>
-          <a:lstStyle/>
-          <a:p>
-            <a:pPr algn="l"/>
-            <a:r>
-              <a:rPr lang="en-US" sz="850" b="1" i="0" dirty="0">
-                <a:solidFill>
-                  <a:srgbClr val="44546A"/>
-                </a:solidFill>
-                <a:latin typeface="Open Sans" panose="020B0606030504020204" pitchFamily="34" charset="0"/>
-              </a:rPr>
-              <a:t/>
-            </a:r>
-          </a:p>
-        </p:txBody>
-      </p:sp>
-      <p:sp>
-        <p:nvSpPr>
-          <p:cNvPr id="32" name="GATE_REASON_5"/>
-          <p:cNvSpPr txBox="1"/>
-          <p:nvPr/>
-        </p:nvSpPr>
-        <p:spPr>
-          <a:xfrm>
-            <a:off x="2921478" y="4418736"/>
-            <a:ext cx="3165340" cy="274320"/>
-          </a:xfrm>
-          <a:prstGeom prst="rect">
-            <a:avLst/>
-          </a:prstGeom>
-          <a:noFill/>
-        </p:spPr>
-        <p:txBody>
-          <a:bodyPr wrap="square" lIns="0" tIns="0" rIns="0" bIns="0" anchor="t">
-            <a:noAutofit/>
-          </a:bodyPr>
-          <a:lstStyle/>
-          <a:p>
-            <a:pPr algn="l"/>
-            <a:r>
-              <a:rPr lang="en-US" sz="900" b="0" i="0" dirty="0">
-                <a:solidFill>
-                  <a:srgbClr val="44546A"/>
-                </a:solidFill>
-                <a:latin typeface="Open Sans" panose="020B0606030504020204" pitchFamily="34" charset="0"/>
-              </a:rPr>
-              <a:t/>
-            </a:r>
-          </a:p>
-        </p:txBody>
-      </p:sp>
-      <p:sp>
-        <p:nvSpPr>
-          <p:cNvPr id="33" name="COMPARISON_BG"/>
-          <p:cNvSpPr/>
-          <p:nvPr/>
-        </p:nvSpPr>
-        <p:spPr>
-          <a:xfrm>
-            <a:off x="6315418" y="2187600"/>
-            <a:ext cx="5228881" cy="2660904"/>
-          </a:xfrm>
-          <a:prstGeom prst="roundRect">
-            <a:avLst>
-              <a:gd name="adj" fmla="val 8000"/>
-            </a:avLst>
-          </a:prstGeom>
-          <a:solidFill>
-            <a:srgbClr val="F8FAFB"/>
-          </a:solidFill>
-          <a:ln>
-            <a:noFill/>
-          </a:ln>
-        </p:spPr>
-        <p:txBody>
-          <a:bodyPr/>
-          <a:lstStyle/>
-          <a:p>
-            <a:endParaRPr lang="en-US"/>
-          </a:p>
-        </p:txBody>
-      </p:sp>
-      <p:sp>
-        <p:nvSpPr>
-          <p:cNvPr id="34" name="SCORE_VENDOR_1"/>
-          <p:cNvSpPr txBox="1"/>
-          <p:nvPr/>
-        </p:nvSpPr>
-        <p:spPr>
-          <a:xfrm>
-            <a:off x="6461722" y="2297328"/>
-            <a:ext cx="2377440" cy="201168"/>
-          </a:xfrm>
-          <a:prstGeom prst="rect">
-            <a:avLst/>
-          </a:prstGeom>
-          <a:noFill/>
-        </p:spPr>
-        <p:txBody>
-          <a:bodyPr wrap="square" lIns="0" tIns="0" rIns="0" bIns="0" anchor="t">
-            <a:noAutofit/>
-          </a:bodyPr>
-          <a:lstStyle/>
-          <a:p>
-            <a:pPr algn="l"/>
-            <a:r>
-              <a:rPr lang="en-US" sz="1050" b="1" i="0" dirty="0">
-                <a:solidFill>
-                  <a:srgbClr val="1A1A2E"/>
-                </a:solidFill>
-                <a:latin typeface="Open Sans" panose="020B0606030504020204" pitchFamily="34" charset="0"/>
-              </a:rPr>
-              <a:t>Northstar</a:t>
-            </a:r>
-          </a:p>
-        </p:txBody>
-      </p:sp>
-      <p:sp>
-        <p:nvSpPr>
-          <p:cNvPr id="35" name="SCORE_TRACK_1"/>
-          <p:cNvSpPr/>
-          <p:nvPr/>
-        </p:nvSpPr>
-        <p:spPr>
-          <a:xfrm>
-            <a:off x="6461722" y="2544216"/>
-            <a:ext cx="3811561" cy="118872"/>
-          </a:xfrm>
-          <a:prstGeom prst="roundRect">
-            <a:avLst>
-              <a:gd name="adj" fmla="val 8000"/>
-            </a:avLst>
-          </a:prstGeom>
-          <a:solidFill>
-            <a:srgbClr val="C7CFD9"/>
-          </a:solidFill>
-          <a:ln>
-            <a:noFill/>
-          </a:ln>
-        </p:spPr>
-        <p:txBody>
-          <a:bodyPr/>
-          <a:lstStyle/>
-          <a:p>
-            <a:endParaRPr lang="en-US"/>
-          </a:p>
-        </p:txBody>
-      </p:sp>
-      <p:sp>
-        <p:nvSpPr>
-          <p:cNvPr id="36" name="SCORE_BAR_1"/>
-          <p:cNvSpPr/>
-          <p:nvPr/>
-        </p:nvSpPr>
-        <p:spPr>
-          <a:xfrm>
-            <a:off x="6461722" y="2544216"/>
-            <a:ext cx="3499013" cy="118872"/>
-          </a:xfrm>
-          <a:prstGeom prst="roundRect">
-            <a:avLst>
-              <a:gd name="adj" fmla="val 8000"/>
-            </a:avLst>
-          </a:prstGeom>
-          <a:solidFill>
-            <a:srgbClr val="003087"/>
-          </a:solidFill>
-          <a:ln>
-            <a:noFill/>
-          </a:ln>
-        </p:spPr>
-        <p:txBody>
-          <a:bodyPr/>
-          <a:lstStyle/>
-          <a:p>
-            <a:endParaRPr lang="en-US"/>
-          </a:p>
-        </p:txBody>
-      </p:sp>
-      <p:sp>
-        <p:nvSpPr>
-          <p:cNvPr id="37" name="SCORE_VALUE_1"/>
-          <p:cNvSpPr txBox="1"/>
-          <p:nvPr/>
-        </p:nvSpPr>
-        <p:spPr>
-          <a:xfrm>
-            <a:off x="10319003" y="2498496"/>
-            <a:ext cx="566928" cy="201168"/>
-          </a:xfrm>
-          <a:prstGeom prst="rect">
-            <a:avLst/>
-          </a:prstGeom>
-          <a:noFill/>
-        </p:spPr>
-        <p:txBody>
-          <a:bodyPr wrap="square" lIns="0" tIns="0" rIns="0" bIns="0" anchor="t">
-            <a:noAutofit/>
-          </a:bodyPr>
-          <a:lstStyle/>
-          <a:p>
-            <a:pPr algn="r"/>
-            <a:r>
-              <a:rPr lang="en-US" sz="1050" b="1" i="0" dirty="0">
-                <a:solidFill>
-                  <a:srgbClr val="1A1A2E"/>
-                </a:solidFill>
-                <a:latin typeface="Open Sans" panose="020B0606030504020204" pitchFamily="34" charset="0"/>
-              </a:rPr>
-              <a:t>91.8</a:t>
-            </a:r>
-          </a:p>
-        </p:txBody>
-      </p:sp>
-      <p:sp>
-        <p:nvSpPr>
-          <p:cNvPr id="38" name="SCORE_LABEL_1"/>
-          <p:cNvSpPr txBox="1"/>
-          <p:nvPr/>
-        </p:nvSpPr>
-        <p:spPr>
-          <a:xfrm>
-            <a:off x="6461722" y="2699664"/>
-            <a:ext cx="4908841" cy="164592"/>
-          </a:xfrm>
-          <a:prstGeom prst="rect">
-            <a:avLst/>
-          </a:prstGeom>
-          <a:noFill/>
-        </p:spPr>
-        <p:txBody>
-          <a:bodyPr wrap="square" lIns="0" tIns="0" rIns="0" bIns="0" anchor="t">
-            <a:noAutofit/>
-          </a:bodyPr>
-          <a:lstStyle/>
-          <a:p>
-            <a:pPr algn="l"/>
-            <a:r>
-              <a:rPr lang="en-US" sz="850" b="0" i="0" dirty="0">
-                <a:solidFill>
-                  <a:srgbClr val="44546A"/>
-                </a:solidFill>
-                <a:latin typeface="Open Sans" panose="020B0606030504020204" pitchFamily="34" charset="0"/>
-              </a:rPr>
-              <a:t>S$348,000 ex GST</a:t>
-            </a:r>
-          </a:p>
-        </p:txBody>
-      </p:sp>
-      <p:sp>
-        <p:nvSpPr>
-          <p:cNvPr id="39" name="SCORE_VENDOR_2"/>
-          <p:cNvSpPr txBox="1"/>
-          <p:nvPr/>
-        </p:nvSpPr>
-        <p:spPr>
-          <a:xfrm>
-            <a:off x="6461722" y="3138576"/>
-            <a:ext cx="2377440" cy="201168"/>
-          </a:xfrm>
-          <a:prstGeom prst="rect">
-            <a:avLst/>
-          </a:prstGeom>
-          <a:noFill/>
-        </p:spPr>
-        <p:txBody>
-          <a:bodyPr wrap="square" lIns="0" tIns="0" rIns="0" bIns="0" anchor="t">
-            <a:noAutofit/>
-          </a:bodyPr>
-          <a:lstStyle/>
-          <a:p>
-            <a:pPr algn="l"/>
-            <a:r>
-              <a:rPr lang="en-US" sz="1050" b="1" i="0" dirty="0">
-                <a:solidFill>
-                  <a:srgbClr val="1A1A2E"/>
-                </a:solidFill>
-                <a:latin typeface="Open Sans" panose="020B0606030504020204" pitchFamily="34" charset="0"/>
-              </a:rPr>
-              <a:t>Meridian</a:t>
-            </a:r>
-          </a:p>
-        </p:txBody>
-      </p:sp>
-      <p:sp>
-        <p:nvSpPr>
-          <p:cNvPr id="40" name="SCORE_TRACK_2"/>
-          <p:cNvSpPr/>
-          <p:nvPr/>
-        </p:nvSpPr>
-        <p:spPr>
-          <a:xfrm>
-            <a:off x="6461722" y="3385464"/>
-            <a:ext cx="3811561" cy="118872"/>
-          </a:xfrm>
-          <a:prstGeom prst="roundRect">
-            <a:avLst>
-              <a:gd name="adj" fmla="val 8000"/>
-            </a:avLst>
-          </a:prstGeom>
-          <a:solidFill>
-            <a:srgbClr val="C7CFD9"/>
-          </a:solidFill>
-          <a:ln>
-            <a:noFill/>
-          </a:ln>
-        </p:spPr>
-        <p:txBody>
-          <a:bodyPr/>
-          <a:lstStyle/>
-          <a:p>
-            <a:endParaRPr lang="en-US"/>
-          </a:p>
-        </p:txBody>
-      </p:sp>
-      <p:sp>
-        <p:nvSpPr>
-          <p:cNvPr id="41" name="SCORE_BAR_2"/>
-          <p:cNvSpPr/>
-          <p:nvPr/>
-        </p:nvSpPr>
-        <p:spPr>
-          <a:xfrm>
-            <a:off x="6461722" y="3385464"/>
-            <a:ext cx="3285566" cy="118872"/>
-          </a:xfrm>
-          <a:prstGeom prst="roundRect">
-            <a:avLst>
-              <a:gd name="adj" fmla="val 8000"/>
-            </a:avLst>
-          </a:prstGeom>
-          <a:solidFill>
-            <a:srgbClr val="003087"/>
-          </a:solidFill>
-          <a:ln>
-            <a:noFill/>
-          </a:ln>
-        </p:spPr>
-        <p:txBody>
-          <a:bodyPr/>
-          <a:lstStyle/>
-          <a:p>
-            <a:endParaRPr lang="en-US"/>
-          </a:p>
-        </p:txBody>
-      </p:sp>
-      <p:sp>
-        <p:nvSpPr>
-          <p:cNvPr id="42" name="SCORE_VALUE_2"/>
-          <p:cNvSpPr txBox="1"/>
-          <p:nvPr/>
-        </p:nvSpPr>
-        <p:spPr>
-          <a:xfrm>
-            <a:off x="10319003" y="3339744"/>
-            <a:ext cx="566928" cy="201168"/>
-          </a:xfrm>
-          <a:prstGeom prst="rect">
-            <a:avLst/>
-          </a:prstGeom>
-          <a:noFill/>
-        </p:spPr>
-        <p:txBody>
-          <a:bodyPr wrap="square" lIns="0" tIns="0" rIns="0" bIns="0" anchor="t">
-            <a:noAutofit/>
-          </a:bodyPr>
-          <a:lstStyle/>
-          <a:p>
-            <a:pPr algn="r"/>
-            <a:r>
-              <a:rPr lang="en-US" sz="1050" b="1" i="0" dirty="0">
-                <a:solidFill>
-                  <a:srgbClr val="1A1A2E"/>
-                </a:solidFill>
-                <a:latin typeface="Open Sans" panose="020B0606030504020204" pitchFamily="34" charset="0"/>
-              </a:rPr>
-              <a:t>86.2</a:t>
-            </a:r>
-          </a:p>
-        </p:txBody>
-      </p:sp>
-      <p:sp>
-        <p:nvSpPr>
-          <p:cNvPr id="43" name="SCORE_LABEL_2"/>
-          <p:cNvSpPr txBox="1"/>
-          <p:nvPr/>
-        </p:nvSpPr>
-        <p:spPr>
-          <a:xfrm>
-            <a:off x="6461722" y="3540912"/>
-            <a:ext cx="4908841" cy="164592"/>
-          </a:xfrm>
-          <a:prstGeom prst="rect">
-            <a:avLst/>
-          </a:prstGeom>
-          <a:noFill/>
-        </p:spPr>
-        <p:txBody>
-          <a:bodyPr wrap="square" lIns="0" tIns="0" rIns="0" bIns="0" anchor="t">
-            <a:noAutofit/>
-          </a:bodyPr>
-          <a:lstStyle/>
-          <a:p>
-            <a:pPr algn="l"/>
-            <a:r>
-              <a:rPr lang="en-US" sz="850" b="0" i="0" dirty="0">
-                <a:solidFill>
-                  <a:srgbClr val="44546A"/>
-                </a:solidFill>
-                <a:latin typeface="Open Sans" panose="020B0606030504020204" pitchFamily="34" charset="0"/>
-              </a:rPr>
-              <a:t>S$391,500 ex GST</a:t>
-            </a:r>
-          </a:p>
-        </p:txBody>
-      </p:sp>
-      <p:sp>
-        <p:nvSpPr>
-          <p:cNvPr id="44" name="SCORE_VENDOR_3"/>
-          <p:cNvSpPr txBox="1"/>
-          <p:nvPr/>
-        </p:nvSpPr>
-        <p:spPr>
-          <a:xfrm>
-            <a:off x="6461722" y="3979824"/>
-            <a:ext cx="2377440" cy="201168"/>
-          </a:xfrm>
-          <a:prstGeom prst="rect">
-            <a:avLst/>
-          </a:prstGeom>
-          <a:noFill/>
-        </p:spPr>
-        <p:txBody>
-          <a:bodyPr wrap="square" lIns="0" tIns="0" rIns="0" bIns="0" anchor="t">
-            <a:noAutofit/>
-          </a:bodyPr>
-          <a:lstStyle/>
-          <a:p>
-            <a:pPr algn="l"/>
-            <a:r>
-              <a:rPr lang="en-US" sz="1050" b="1" i="0" dirty="0">
-                <a:solidFill>
-                  <a:srgbClr val="1A1A2E"/>
-                </a:solidFill>
-                <a:latin typeface="Open Sans" panose="020B0606030504020204" pitchFamily="34" charset="0"/>
-              </a:rPr>
-              <a:t>Helix</a:t>
-            </a:r>
-          </a:p>
-        </p:txBody>
-      </p:sp>
-      <p:sp>
-        <p:nvSpPr>
-          <p:cNvPr id="45" name="SCORE_TRACK_3"/>
-          <p:cNvSpPr/>
-          <p:nvPr/>
-        </p:nvSpPr>
-        <p:spPr>
-          <a:xfrm>
-            <a:off x="6461722" y="4226712"/>
-            <a:ext cx="3811561" cy="118872"/>
-          </a:xfrm>
-          <a:prstGeom prst="roundRect">
-            <a:avLst>
-              <a:gd name="adj" fmla="val 8000"/>
-            </a:avLst>
-          </a:prstGeom>
-          <a:solidFill>
-            <a:srgbClr val="C7CFD9"/>
-          </a:solidFill>
-          <a:ln>
-            <a:noFill/>
-          </a:ln>
-        </p:spPr>
-        <p:txBody>
-          <a:bodyPr/>
-          <a:lstStyle/>
-          <a:p>
-            <a:endParaRPr lang="en-US"/>
-          </a:p>
-        </p:txBody>
-      </p:sp>
-      <p:sp>
-        <p:nvSpPr>
-          <p:cNvPr id="46" name="SCORE_BAR_3"/>
-          <p:cNvSpPr/>
-          <p:nvPr/>
-        </p:nvSpPr>
-        <p:spPr>
-          <a:xfrm>
-            <a:off x="6461722" y="4226712"/>
-            <a:ext cx="3102611" cy="118872"/>
-          </a:xfrm>
-          <a:prstGeom prst="roundRect">
-            <a:avLst>
-              <a:gd name="adj" fmla="val 8000"/>
-            </a:avLst>
-          </a:prstGeom>
-          <a:solidFill>
-            <a:srgbClr val="003087"/>
-          </a:solidFill>
-          <a:ln>
-            <a:noFill/>
-          </a:ln>
-        </p:spPr>
-        <p:txBody>
-          <a:bodyPr/>
-          <a:lstStyle/>
-          <a:p>
-            <a:endParaRPr lang="en-US"/>
-          </a:p>
-        </p:txBody>
-      </p:sp>
-      <p:sp>
-        <p:nvSpPr>
-          <p:cNvPr id="47" name="SCORE_VALUE_3"/>
-          <p:cNvSpPr txBox="1"/>
-          <p:nvPr/>
-        </p:nvSpPr>
-        <p:spPr>
-          <a:xfrm>
-            <a:off x="10319003" y="4180992"/>
-            <a:ext cx="566928" cy="201168"/>
-          </a:xfrm>
-          <a:prstGeom prst="rect">
-            <a:avLst/>
-          </a:prstGeom>
-          <a:noFill/>
-        </p:spPr>
-        <p:txBody>
-          <a:bodyPr wrap="square" lIns="0" tIns="0" rIns="0" bIns="0" anchor="t">
-            <a:noAutofit/>
-          </a:bodyPr>
-          <a:lstStyle/>
-          <a:p>
-            <a:pPr algn="r"/>
-            <a:r>
-              <a:rPr lang="en-US" sz="1050" b="1" i="0" dirty="0">
-                <a:solidFill>
-                  <a:srgbClr val="1A1A2E"/>
-                </a:solidFill>
-                <a:latin typeface="Open Sans" panose="020B0606030504020204" pitchFamily="34" charset="0"/>
-              </a:rPr>
-              <a:t>81.4</a:t>
-            </a:r>
-          </a:p>
-        </p:txBody>
-      </p:sp>
-      <p:sp>
-        <p:nvSpPr>
-          <p:cNvPr id="48" name="SCORE_LABEL_3"/>
-          <p:cNvSpPr txBox="1"/>
-          <p:nvPr/>
-        </p:nvSpPr>
-        <p:spPr>
-          <a:xfrm>
-            <a:off x="6461722" y="4382160"/>
-            <a:ext cx="4908841" cy="164592"/>
-          </a:xfrm>
-          <a:prstGeom prst="rect">
-            <a:avLst/>
-          </a:prstGeom>
-          <a:noFill/>
-        </p:spPr>
-        <p:txBody>
-          <a:bodyPr wrap="square" lIns="0" tIns="0" rIns="0" bIns="0" anchor="t">
-            <a:noAutofit/>
-          </a:bodyPr>
-          <a:lstStyle/>
-          <a:p>
-            <a:pPr algn="l"/>
-            <a:r>
-              <a:rPr lang="en-US" sz="850" b="0" i="0" dirty="0">
-                <a:solidFill>
-                  <a:srgbClr val="44546A"/>
-                </a:solidFill>
-                <a:latin typeface="Open Sans" panose="020B0606030504020204" pitchFamily="34" charset="0"/>
-              </a:rPr>
-              <a:t>S$422,000 ex GST</a:t>
-            </a:r>
-          </a:p>
-        </p:txBody>
-      </p:sp>
-      <p:sp>
-        <p:nvSpPr>
-          <p:cNvPr id="49" name="DECISION_PANEL"/>
-          <p:cNvSpPr/>
-          <p:nvPr/>
-        </p:nvSpPr>
-        <p:spPr>
-          <a:xfrm>
-            <a:off x="629336" y="5013096"/>
-            <a:ext cx="10914963" cy="530352"/>
-          </a:xfrm>
-          <a:prstGeom prst="roundRect">
-            <a:avLst>
-              <a:gd name="adj" fmla="val 8000"/>
-            </a:avLst>
-          </a:prstGeom>
-          <a:solidFill>
-            <a:srgbClr val="003087"/>
-          </a:solidFill>
-          <a:ln>
-            <a:noFill/>
-          </a:ln>
-        </p:spPr>
-        <p:txBody>
-          <a:bodyPr/>
-          <a:lstStyle/>
-          <a:p>
-            <a:endParaRPr lang="en-US"/>
-          </a:p>
-        </p:txBody>
-      </p:sp>
-      <p:sp>
-        <p:nvSpPr>
-          <p:cNvPr id="50" name="DECISION"/>
-          <p:cNvSpPr txBox="1"/>
-          <p:nvPr/>
-        </p:nvSpPr>
-        <p:spPr>
-          <a:xfrm>
-            <a:off x="830504" y="5113680"/>
-            <a:ext cx="10549203" cy="329184"/>
-          </a:xfrm>
-          <a:prstGeom prst="rect">
-            <a:avLst/>
-          </a:prstGeom>
-          <a:noFill/>
-        </p:spPr>
-        <p:txBody>
-          <a:bodyPr wrap="square" lIns="0" tIns="0" rIns="0" bIns="0" anchor="ctr">
-            <a:noAutofit/>
-          </a:bodyPr>
-          <a:lstStyle/>
-          <a:p>
-            <a:pPr algn="l"/>
-            <a:r>
-              <a:rPr lang="en-US" sz="1400" b="1" i="0" dirty="0">
-                <a:solidFill>
-                  <a:srgbClr val="FFFFFF"/>
-                </a:solidFill>
-                <a:latin typeface="Open Sans" panose="020B0606030504020204" pitchFamily="34" charset="0"/>
-              </a:rPr>
-              <a:t>Approve Northstar at S$348,000 ex GST</a:t>
-            </a:r>
-          </a:p>
-        </p:txBody>
-      </p:sp>
-      <p:sp>
-        <p:nvSpPr>
-          <p:cNvPr id="51" name="SOURCE_NOTES"/>
-          <p:cNvSpPr txBox="1"/>
-          <p:nvPr/>
-        </p:nvSpPr>
-        <p:spPr>
-          <a:xfrm>
-            <a:off x="629336" y="5689752"/>
-            <a:ext cx="10914963" cy="237744"/>
-          </a:xfrm>
-          <a:prstGeom prst="rect">
-            <a:avLst/>
-          </a:prstGeom>
-          <a:noFill/>
-        </p:spPr>
-        <p:txBody>
-          <a:bodyPr wrap="square" lIns="0" tIns="0" rIns="0" bIns="0" anchor="t">
-            <a:noAutofit/>
-          </a:bodyPr>
-          <a:lstStyle/>
-          <a:p>
-            <a:pPr algn="l"/>
-            <a:r>
-              <a:rPr lang="en-US" sz="850" b="0" i="0" dirty="0">
-                <a:solidFill>
-                  <a:srgbClr val="44546A"/>
-                </a:solidFill>
-                <a:latin typeface="Open Sans" panose="020B0606030504020204" pitchFamily="34" charset="0"/>
-              </a:rPr>
-              <a:t>Sources: RFQ-02 M1-M7; NST-05 service term; EMAIL-02 service clarification thread; EVAL-01 summary scores; EVAL-02 proposal comparison. Fictional training case.</a:t>
+              <a:t>Sources: N/A. Fictional training case.</a:t>
             </a:r>
           </a:p>
         </p:txBody>

</xml_diff>